<commit_message>
Add Signal Claw Neural Link page and homepage teaser.
Ship /signal with horizon visual, honest Tier C preview copy, and pitch deck alignment so investors see the device-hub story without overselling integration depth.

Co-authored-by: Cursor <cursoragent@cursor.com>
</commit_message>
<xml_diff>
--- a/docs/CurXor-Pitch-Deck-Speaker-Notes.pptx
+++ b/docs/CurXor-Pitch-Deck-Speaker-Notes.pptx
@@ -992,7 +992,7 @@
           </a:p>
           <a:p>
             <a:r>
-              <a:t>v0.1.0 · 14/14 QA smoke · pre-order live — say each number out loud.</a:t>
+              <a:t>v0.2.0 · 54 QA checks · pre-order live — say each number out loud.</a:t>
             </a:r>
           </a:p>
           <a:p/>
@@ -1821,7 +1821,7 @@
           </a:p>
           <a:p>
             <a:r>
-              <a:t>• v0.1.0 stable, CI green, fourteen API smoke tests passing.</a:t>
+              <a:t>• v0.2.0 stable — agent runtime, unified comms, fifty-four QA checks passing.</a:t>
             </a:r>
           </a:p>
           <a:p>
@@ -2009,7 +2009,7 @@
           </a:p>
           <a:p>
             <a:r>
-              <a:t>Forge mints custom Claws; we also ship eight digital employees out of the box.</a:t>
+              <a:t>Forge mints custom Claws; we also ship ten digital employees out of the box.</a:t>
             </a:r>
           </a:p>
         </p:txBody>
@@ -2084,7 +2084,7 @@
           </a:p>
           <a:p>
             <a:r>
-              <a:t>Read the roster confidently; investors should hear "complete suite," not "eight random apps."</a:t>
+              <a:t>Read the roster confidently; investors should hear "complete suite," not "ten random apps."</a:t>
             </a:r>
           </a:p>
           <a:p/>
@@ -2120,17 +2120,27 @@
           </a:p>
           <a:p>
             <a:r>
-              <a:t>• Signal Claw — feed triggers, alert thresholds</a:t>
-            </a:r>
-          </a:p>
-          <a:p>
-            <a:r>
-              <a:t>• Swarm Claw — parallel Claw orchestration</a:t>
+              <a:t>• Signal Claw — The Neural Link: humanoid preview; device hub for glance, VR, robot, home, fleet</a:t>
+            </a:r>
+          </a:p>
+          <a:p>
+            <a:r>
+              <a:t>• Swarm Claw — robotaxi fleet preview from sovereign metal</a:t>
             </a:r>
           </a:p>
           <a:p>
             <a:r>
               <a:t>• Engage Claw — community and DM engagement demos</a:t>
+            </a:r>
+          </a:p>
+          <a:p>
+            <a:r>
+              <a:t>• Vital Claw — wearables, labs, longevity protocol</a:t>
+            </a:r>
+          </a:p>
+          <a:p>
+            <a:r>
+              <a:t>• Kin Claw — household profiles, devices, personalities</a:t>
             </a:r>
           </a:p>
           <a:p/>
@@ -6029,7 +6039,7 @@
                 </a:solidFill>
                 <a:latin typeface="Consolas"/>
               </a:rPr>
-              <a:t>v0.1.0 · June 2026 · Sovereign Agent Appliance</a:t>
+              <a:t>v0.2.0 · June 2026 · Sovereign Agent Appliance</a:t>
             </a:r>
           </a:p>
         </p:txBody>
@@ -7279,7 +7289,7 @@
                 </a:solidFill>
                 <a:latin typeface="Segoe UI"/>
               </a:rPr>
-              <a:t>v0.1.0 · QA smoke 14/14 · Pre-order live</a:t>
+              <a:t>v0.2.0 · 54 QA checks · Pre-order live</a:t>
             </a:r>
           </a:p>
         </p:txBody>
@@ -7637,7 +7647,7 @@
                 </a:solidFill>
                 <a:latin typeface="Segoe UI"/>
               </a:rPr>
-              <a:t>Now (v0.1.0): scaffold · GTM live · CI green · QA smoke</a:t>
+              <a:t>Now (v0.2.0): agent runtime · unified comms · 54 QA · build mode</a:t>
             </a:r>
           </a:p>
           <a:p>
@@ -8477,7 +8487,7 @@
                           </a:solidFill>
                           <a:latin typeface="Segoe UI"/>
                         </a:rPr>
-                        <a:t>Software scaffold v0.1.0</a:t>
+                        <a:t>Software v0.2.0</a:t>
                       </a:r>
                     </a:p>
                   </a:txBody>
@@ -8495,7 +8505,7 @@
                           </a:solidFill>
                           <a:latin typeface="Segoe UI"/>
                         </a:rPr>
-                        <a:t>Complete · CI green</a:t>
+                        <a:t>Agent runtime · 54 QA checks</a:t>
                       </a:r>
                     </a:p>
                   </a:txBody>
@@ -10049,7 +10059,7 @@
                 </a:solidFill>
                 <a:latin typeface="Segoe UI"/>
               </a:rPr>
-              <a:t>curxor-os — appliance: /opt/curxor/, systemd, OTA · v0.1.0 · 14/14 QA</a:t>
+              <a:t>curxor-os — appliance: /opt/curxor/, systemd, OTA · v0.2.0 · 54 QA checks</a:t>
             </a:r>
           </a:p>
           <a:p>
@@ -10827,7 +10837,7 @@
                 </a:solidFill>
                 <a:latin typeface="Segoe UI"/>
               </a:rPr>
-              <a:t>Eight Claws — digital employees OOTB</a:t>
+              <a:t>Ten Claws — digital employees OOTB</a:t>
             </a:r>
           </a:p>
         </p:txBody>
@@ -10925,7 +10935,7 @@
                 </a:solidFill>
                 <a:latin typeface="Segoe UI"/>
               </a:rPr>
-              <a:t>Signal · Swarm · Engage</a:t>
+              <a:t>Signal · Swarm · Engage · Vital · Kin</a:t>
             </a:r>
           </a:p>
           <a:p>

</xml_diff>

<commit_message>
Fundraising polish: hybrid H1, unified operators, investor journey fixes.
Align site and pitch deck for diligence — proof-first homepage, Alex/Sam/Jordan everywhere, press kit links to G3 demo, dead code purge, and ESLint CLI migration.
</commit_message>
<xml_diff>
--- a/docs/CurXor-Pitch-Deck-Speaker-Notes.pptx
+++ b/docs/CurXor-Pitch-Deck-Speaker-Notes.pptx
@@ -992,7 +992,7 @@
           </a:p>
           <a:p>
             <a:r>
-              <a:t>v0.2.0 · 54 QA checks · pre-order live — say each number out loud.</a:t>
+              <a:t>v0.9.1 · ~176 smoke + ~40 user flows · pre-order live — say each number out loud.</a:t>
             </a:r>
           </a:p>
           <a:p/>
@@ -1821,7 +1821,7 @@
           </a:p>
           <a:p>
             <a:r>
-              <a:t>• v0.2.0 stable — agent runtime, unified comms, fifty-four QA checks passing.</a:t>
+              <a:t>• v0.9.1 stable — agent runtime, unified comms, Build Plane BP4, ~176 smoke + ~40 user flows in qa:local.</a:t>
             </a:r>
           </a:p>
           <a:p>
@@ -6039,7 +6039,7 @@
                 </a:solidFill>
                 <a:latin typeface="Consolas"/>
               </a:rPr>
-              <a:t>v0.2.0 · June 2026 · Sovereign Agent Appliance</a:t>
+              <a:t>v0.9.1 · June 2026 · Sovereign Agent Appliance</a:t>
             </a:r>
           </a:p>
         </p:txBody>
@@ -7289,7 +7289,7 @@
                 </a:solidFill>
                 <a:latin typeface="Segoe UI"/>
               </a:rPr>
-              <a:t>v0.2.0 · 54 QA checks · Pre-order live</a:t>
+              <a:t>v0.9.1 · ~216 QA checks · Pre-order live</a:t>
             </a:r>
           </a:p>
         </p:txBody>
@@ -7647,7 +7647,7 @@
                 </a:solidFill>
                 <a:latin typeface="Segoe UI"/>
               </a:rPr>
-              <a:t>Now (v0.2.0): agent runtime · unified comms · 54 QA · build mode</a:t>
+              <a:t>Now (v0.9.1): agent runtime · unified comms · Build Plane BP4 · ~216 QA · GTM live</a:t>
             </a:r>
           </a:p>
           <a:p>
@@ -8487,7 +8487,7 @@
                           </a:solidFill>
                           <a:latin typeface="Segoe UI"/>
                         </a:rPr>
-                        <a:t>Software v0.2.0</a:t>
+                        <a:t>Software v0.9.1</a:t>
                       </a:r>
                     </a:p>
                   </a:txBody>
@@ -8505,7 +8505,7 @@
                           </a:solidFill>
                           <a:latin typeface="Segoe UI"/>
                         </a:rPr>
-                        <a:t>Agent runtime · 54 QA checks</a:t>
+                        <a:t>Agent runtime · ~176 smoke + ~40 user flows</a:t>
                       </a:r>
                     </a:p>
                   </a:txBody>
@@ -10059,7 +10059,7 @@
                 </a:solidFill>
                 <a:latin typeface="Segoe UI"/>
               </a:rPr>
-              <a:t>curxor-os — appliance: /opt/curxor/, systemd, OTA · v0.2.0 · 54 QA checks</a:t>
+              <a:t>curxor-os — appliance: /opt/curxor/, systemd, OTA · v0.9.1 · ~216 QA checks</a:t>
             </a:r>
           </a:p>
           <a:p>

</xml_diff>

<commit_message>
Refresh pitch deck PPTX and appliance sync timestamps.
Regenerated speaker notes deck after badge film URL wiring; sync metadata from latest prebuild.

Co-authored-by: Cursor <cursoragent@cursor.com>
</commit_message>
<xml_diff>
--- a/docs/CurXor-Pitch-Deck-Speaker-Notes.pptx
+++ b/docs/CurXor-Pitch-Deck-Speaker-Notes.pptx
@@ -16,10 +16,6 @@
     <p:sldId id="264" r:id="rId16"/>
     <p:sldId id="265" r:id="rId17"/>
     <p:sldId id="266" r:id="rId18"/>
-    <p:sldId id="267" r:id="rId19"/>
-    <p:sldId id="268" r:id="rId20"/>
-    <p:sldId id="269" r:id="rId21"/>
-    <p:sldId id="270" r:id="rId22"/>
   </p:sldIdLst>
   <p:sldSz cx="12191695" cy="6858000" type="screen4x3"/>
   <p:notesSz cx="6858000" cy="9144000"/>
@@ -521,66 +517,60 @@
           </a:p>
           <a:p>
             <a:r>
-              <a:t>Pause on the title. This is not another AI wrapper — it is a sovereign agent appliance.</a:t>
+              <a:t>Hybrid hero — not personal cloud, not another chat tab.</a:t>
             </a:r>
           </a:p>
           <a:p/>
           <a:p>
             <a:r>
-              <a:t>KEY MESSAGE</a:t>
-            </a:r>
-          </a:p>
-          <a:p>
-            <a:r>
-              <a:t>CurXor OS mints autonomous digital employees on bare metal. One hardware purchase replaces recurring API rent for operators who run agents 24/7.</a:t>
+              <a:t>REGISTERS</a:t>
+            </a:r>
+          </a:p>
+          <a:p>
+            <a:r>
+              <a:t>• Sovereignty investors: owned metal · no API rent · egress boundary · MS-S1 proof.</a:t>
+            </a:r>
+          </a:p>
+          <a:p>
+            <a:r>
+              <a:t>• Product investors: Capital · Creator · Work · Forge · Cafe · desk orchestrator.</a:t>
             </a:r>
           </a:p>
           <a:p/>
           <a:p>
             <a:r>
-              <a:t>WALK THROUGH METRICS</a:t>
-            </a:r>
-          </a:p>
-          <a:p>
-            <a:r>
-              <a:t>• $3,999 — MS-S1 MAX bundle, one invoice, no subscription required for inference.</a:t>
-            </a:r>
-          </a:p>
-          <a:p>
-            <a:r>
-              <a:t>• $0/mo API — local Ollama/vLLM on localhost; you own the compute.</a:t>
-            </a:r>
-          </a:p>
-          <a:p>
-            <a:r>
-              <a:t>• 126 TOPS — Ryzen AI Max+ NPU on desk, not rate-limited cloud tiers.</a:t>
-            </a:r>
-          </a:p>
-          <a:p>
-            <a:r>
-              <a:t>• 64 GB UMA — unified memory for 7B–35B models alongside the agent stack.</a:t>
+              <a:t>METRICS</a:t>
+            </a:r>
+          </a:p>
+          <a:p>
+            <a:r>
+              <a:t>• Raise: $3M seed SAFE · 18 months · ≤5 people.</a:t>
+            </a:r>
+          </a:p>
+          <a:p>
+            <a:r>
+              <a:t>• Price: $3,999 once · $0/mo operate plane.</a:t>
+            </a:r>
+          </a:p>
+          <a:p>
+            <a:r>
+              <a:t>• Stage: G1/G2/G3 green · pre-revenue · solo founder.</a:t>
             </a:r>
           </a:p>
           <a:p/>
           <a:p>
             <a:r>
-              <a:t>TAGLINE (say it slowly)</a:t>
-            </a:r>
-          </a:p>
-          <a:p>
-            <a:r>
-              <a:t>"ChatGPT bills per token. CurXor bills once. Alpha stays on your metal."</a:t>
-            </a:r>
-          </a:p>
-          <a:p/>
-          <a:p>
-            <a:r>
-              <a:t>TRANSITION</a:t>
-            </a:r>
-          </a:p>
-          <a:p>
-            <a:r>
-              <a:t>Before we show the product, let me frame the problem every power user already feels.</a:t>
+              <a:t>CLOSE TITLE</a:t>
+            </a:r>
+          </a:p>
+          <a:p>
+            <a:r>
+              <a:t>Best next step is live LAN demo on :3080 — not a cloud sandbox.</a:t>
+            </a:r>
+          </a:p>
+          <a:p>
+            <a:r>
+              <a:t>Proof: curxor.ai/demo/investor/g3-inception-reel-v1.mp4</a:t>
             </a:r>
           </a:p>
         </p:txBody>
@@ -650,65 +640,58 @@
           <a:lstStyle/>
           <a:p>
             <a:r>
-              <a:t>GO-TO-MARKET (45 sec)</a:t>
-            </a:r>
-          </a:p>
-          <a:p>
-            <a:r>
-              <a:t>Tie each segment to a Claw — makes the suite tangible.</a:t>
+              <a:t>CLOSE (60 sec)</a:t>
+            </a:r>
+          </a:p>
+          <a:p>
+            <a:r>
+              <a:t>Warm conversations only.</a:t>
+            </a:r>
+          </a:p>
+          <a:p>
+            <a:r>
+              <a:t>Leave inception reel for async; insist on live box when they engage.</a:t>
+            </a:r>
+          </a:p>
+          <a:p>
+            <a:r>
+              <a:t>Closing: sovereign metal · digital employees · one invoice.</a:t>
             </a:r>
           </a:p>
           <a:p/>
           <a:p>
             <a:r>
-              <a:t>PERSONA → PAIN → ANSWER</a:t>
-            </a:r>
-          </a:p>
-          <a:p>
-            <a:r>
-              <a:t>• Algo trader: API fees and strategy leakage → Capital Claw, localhost rules, Alpaca on eno2 only when skill invoked.</a:t>
-            </a:r>
-          </a:p>
-          <a:p>
-            <a:r>
-              <a:t>• Creator: token rent and lock-in → Creator Claw, local inference, X bridge on explicit post skill.</a:t>
-            </a:r>
-          </a:p>
-          <a:p>
-            <a:r>
-              <a:t>• Outbound/agency: CRM + lead SaaS stack → Outreach Claw on-box.</a:t>
-            </a:r>
-          </a:p>
-          <a:p>
-            <a:r>
-              <a:t>• E-com/arbitrage: margin tools + fulfillment SaaS → Arbitrage Claw.</a:t>
-            </a:r>
-          </a:p>
-          <a:p>
-            <a:r>
-              <a:t>• Sovereignty-maximalist: alpha exfil fear → physical eno2 kill switch narrative.</a:t>
-            </a:r>
-          </a:p>
-          <a:p/>
-          <a:p>
-            <a:r>
-              <a:t>SALES MOTION</a:t>
-            </a:r>
-          </a:p>
-          <a:p>
-            <a:r>
-              <a:t>Storefront captures pre-orders; first units ship to operators who already feel the cloud tax — not hobbyists.</a:t>
-            </a:r>
-          </a:p>
-          <a:p/>
-          <a:p>
-            <a:r>
-              <a:t>TRANSITION</a:t>
-            </a:r>
-          </a:p>
-          <a:p>
-            <a:r>
-              <a:t>Why we win against DIY and SaaS incumbents.</a:t>
+              <a:t>LINKS</a:t>
+            </a:r>
+          </a:p>
+          <a:p>
+            <a:r>
+              <a:t>https://curxor.ai</a:t>
+            </a:r>
+          </a:p>
+          <a:p>
+            <a:r>
+              <a:t>https://curxor.ai/signal#category-film</a:t>
+            </a:r>
+          </a:p>
+          <a:p>
+            <a:r>
+              <a:t>https://curxor.ai/demo/hero-category-badge-v1.mp4</a:t>
+            </a:r>
+          </a:p>
+          <a:p>
+            <a:r>
+              <a:t>https://curxor.ai/demo/investor/g3-inception-reel-v1.mp4</a:t>
+            </a:r>
+          </a:p>
+          <a:p>
+            <a:r>
+              <a:t>https://curxor.ai/demo/investor/g3-investor-proof-v1.mp4</a:t>
+            </a:r>
+          </a:p>
+          <a:p>
+            <a:r>
+              <a:t>https://curxor.ai/press</a:t>
             </a:r>
           </a:p>
         </p:txBody>
@@ -778,682 +761,87 @@
           <a:lstStyle/>
           <a:p>
             <a:r>
-              <a:t>COMPETITIVE (45 sec)</a:t>
-            </a:r>
-          </a:p>
-          <a:p>
-            <a:r>
-              <a:t>Five rows — pick three based on audience.</a:t>
+              <a:t>APPENDIX / Q&amp;A (present only if asked)</a:t>
             </a:r>
           </a:p>
           <a:p/>
           <a:p>
             <a:r>
-              <a:t>DIY OLLAMA</a:t>
-            </a:r>
-          </a:p>
-          <a:p>
-            <a:r>
-              <a:t>Complete stack beats parts bin: FRE provisioning, Forge factory, mesh, OTA, digital bridges.</a:t>
+              <a:t>MATURITY</a:t>
+            </a:r>
+          </a:p>
+          <a:p>
+            <a:r>
+              <a:t>• v1.0.3 appliance green — G1/G2/G3 closed Jul 8.</a:t>
+            </a:r>
+          </a:p>
+          <a:p>
+            <a:r>
+              <a:t>• Flagship desks: Capital paper, Creator queue, Work pipeline on camera.</a:t>
+            </a:r>
+          </a:p>
+          <a:p>
+            <a:r>
+              <a:t>• Bridges: coded; Ops Wave 1 keys founder-gated.</a:t>
+            </a:r>
+          </a:p>
+          <a:p>
+            <a:r>
+              <a:t>• Custom CurXor hardware: Act II post-raise.</a:t>
             </a:r>
           </a:p>
           <a:p/>
           <a:p>
             <a:r>
-              <a:t>SAAS AGENTS</a:t>
-            </a:r>
-          </a:p>
-          <a:p>
-            <a:r>
-              <a:t>Alpha stays local. Outbound is explicit skill → bridge — auditable, not prompt injection to the open web.</a:t>
+              <a:t>DISCLAIMERS</a:t>
+            </a:r>
+          </a:p>
+          <a:p>
+            <a:r>
+              <a:t>• No guaranteed returns. Capital paper/live via Alpaca — strategy-dependent.</a:t>
+            </a:r>
+          </a:p>
+          <a:p>
+            <a:r>
+              <a:t>• Posts require operator approval skill — no autonomous publish.</a:t>
             </a:r>
           </a:p>
           <a:p/>
           <a:p>
             <a:r>
-              <a:t>CLOUD TIERS</a:t>
-            </a:r>
-          </a:p>
-          <a:p>
-            <a:r>
-              <a:t>24/7 agent workloads hit rate limits and token meters. Desk NPU runs flat once hardware is paid.</a:t>
+              <a:t>COMMON Q</a:t>
+            </a:r>
+          </a:p>
+          <a:p>
+            <a:r>
+              <a:t>Q: Just Ollama on a PC?</a:t>
+            </a:r>
+          </a:p>
+          <a:p>
+            <a:r>
+              <a:t>A: Flight Command + ten Claws + Forge + Cafe + eno2 kill switch + OTA — appliance product.</a:t>
             </a:r>
           </a:p>
           <a:p/>
           <a:p>
             <a:r>
-              <a:t>DIGITAL WEALTH PIVOT</a:t>
-            </a:r>
-          </a:p>
-          <a:p>
-            <a:r>
-              <a:t>We sell digital employees with ROI language — not robotics novelty. "Mint employees" resonates with traders and creators.</a:t>
+              <a:t>Q: Why $3,999 vs €549 boxes?</a:t>
+            </a:r>
+          </a:p>
+          <a:p>
+            <a:r>
+              <a:t>A: Operator desks + 64GB UMA + depth — filter for buyers who run Capital/Creator/Work, not chat bots.</a:t>
             </a:r>
           </a:p>
           <a:p/>
           <a:p>
             <a:r>
-              <a:t>SECURITY</a:t>
-            </a:r>
-          </a:p>
-          <a:p>
-            <a:r>
-              <a:t>Two-port architecture with physical kill switch — enterprises understand unplugging egress.</a:t>
-            </a:r>
-          </a:p>
-          <a:p/>
-          <a:p>
-            <a:r>
-              <a:t>TRANSITION</a:t>
-            </a:r>
-          </a:p>
-          <a:p>
-            <a:r>
-              <a:t>What is actually shipped today vs what is gated on hardware.</a:t>
-            </a:r>
-          </a:p>
-        </p:txBody>
-      </p:sp>
-      <p:sp>
-        <p:nvSpPr>
-          <p:cNvPr id="4" name="Slide Number Placeholder 3"/>
-          <p:cNvSpPr>
-            <a:spLocks noGrp="1"/>
-          </p:cNvSpPr>
-          <p:nvPr>
-            <p:ph type="sldNum" idx="5" sz="quarter"/>
-          </p:nvPr>
-        </p:nvSpPr>
-        <p:spPr/>
-      </p:sp>
-    </p:spTree>
-  </p:cSld>
-  <p:clrMapOvr>
-    <a:masterClrMapping/>
-  </p:clrMapOvr>
-</p:notes>
-</file>
-
-<file path=ppt/notesSlides/notesSlide12.xml><?xml version="1.0" encoding="utf-8"?>
-<p:notes xmlns:a="http://schemas.openxmlformats.org/drawingml/2006/main" xmlns:p="http://schemas.openxmlformats.org/presentationml/2006/main" xmlns:r="http://schemas.openxmlformats.org/officeDocument/2006/relationships">
-  <p:cSld>
-    <p:spTree>
-      <p:nvGrpSpPr>
-        <p:cNvPr id="1" name=""/>
-        <p:cNvGrpSpPr/>
-        <p:nvPr/>
-      </p:nvGrpSpPr>
-      <p:grpSpPr>
-        <a:xfrm>
-          <a:off x="0" y="0"/>
-          <a:ext cx="0" cy="0"/>
-          <a:chOff x="0" y="0"/>
-          <a:chExt cx="0" cy="0"/>
-        </a:xfrm>
-      </p:grpSpPr>
-      <p:sp>
-        <p:nvSpPr>
-          <p:cNvPr id="2" name="Slide Image Placeholder 1"/>
-          <p:cNvSpPr>
-            <a:spLocks noGrp="1"/>
-          </p:cNvSpPr>
-          <p:nvPr>
-            <p:ph type="sldImg" idx="2"/>
-          </p:nvPr>
-        </p:nvSpPr>
-        <p:spPr/>
-      </p:sp>
-      <p:sp>
-        <p:nvSpPr>
-          <p:cNvPr id="3" name="Notes Placeholder 2"/>
-          <p:cNvSpPr>
-            <a:spLocks noGrp="1"/>
-          </p:cNvSpPr>
-          <p:nvPr>
-            <p:ph type="body" idx="3" sz="quarter"/>
-          </p:nvPr>
-        </p:nvSpPr>
-        <p:spPr/>
-        <p:txBody>
-          <a:bodyPr/>
-          <a:lstStyle/>
-          <a:p>
-            <a:r>
-              <a:t>PROOF POINTS (60 sec — be precise)</a:t>
-            </a:r>
-          </a:p>
-          <a:p>
-            <a:r>
-              <a:t>Split shipped software from hardware gates again — repetition builds credibility.</a:t>
-            </a:r>
-          </a:p>
-          <a:p/>
-          <a:p>
-            <a:r>
-              <a:t>SHIPPED</a:t>
-            </a:r>
-          </a:p>
-          <a:p>
-            <a:r>
-              <a:t>• Four-pillar install path and systemd target</a:t>
-            </a:r>
-          </a:p>
-          <a:p>
-            <a:r>
-              <a:t>• Flight Command UI with eight Claws and Forge</a:t>
-            </a:r>
-          </a:p>
-          <a:p>
-            <a:r>
-              <a:t>• Local LLM wired: engine + Forge + Creator/Capital dashboard chat</a:t>
-            </a:r>
-          </a:p>
-          <a:p>
-            <a:r>
-              <a:t>• Mesh publish, digital bridges, OTA daemon</a:t>
-            </a:r>
-          </a:p>
-          <a:p>
-            <a:r>
-              <a:t>• Storefront live, appliance catalog sync, CI on both repos</a:t>
-            </a:r>
-          </a:p>
-          <a:p/>
-          <a:p>
-            <a:r>
-              <a:t>PENDING (hardware track)</a:t>
-            </a:r>
-          </a:p>
-          <a:p>
-            <a:r>
-              <a:t>• MS-S1 MAX ROCm/UMA proof on gfx1151</a:t>
-            </a:r>
-          </a:p>
-          <a:p>
-            <a:r>
-              <a:t>• End-to-end mesh latency benchmarks</a:t>
-            </a:r>
-          </a:p>
-          <a:p>
-            <a:r>
-              <a:t>• Golden image freeze + factory USB</a:t>
-            </a:r>
-          </a:p>
-          <a:p>
-            <a:r>
-              <a:t>• Production OTA artifacts + signed releases</a:t>
-            </a:r>
-          </a:p>
-          <a:p/>
-          <a:p>
-            <a:r>
-              <a:t>METRICS ON SLIDE</a:t>
-            </a:r>
-          </a:p>
-          <a:p>
-            <a:r>
-              <a:t>v0.9.1 · ~176 smoke + ~40 user flows · pre-order live — say each number out loud.</a:t>
-            </a:r>
-          </a:p>
-          <a:p/>
-          <a:p>
-            <a:r>
-              <a:t>TRANSITION</a:t>
-            </a:r>
-          </a:p>
-          <a:p>
-            <a:r>
-              <a:t>Here is how we close the hardware gate and scale.</a:t>
-            </a:r>
-          </a:p>
-        </p:txBody>
-      </p:sp>
-      <p:sp>
-        <p:nvSpPr>
-          <p:cNvPr id="4" name="Slide Number Placeholder 3"/>
-          <p:cNvSpPr>
-            <a:spLocks noGrp="1"/>
-          </p:cNvSpPr>
-          <p:nvPr>
-            <p:ph type="sldNum" idx="5" sz="quarter"/>
-          </p:nvPr>
-        </p:nvSpPr>
-        <p:spPr/>
-      </p:sp>
-    </p:spTree>
-  </p:cSld>
-  <p:clrMapOvr>
-    <a:masterClrMapping/>
-  </p:clrMapOvr>
-</p:notes>
-</file>
-
-<file path=ppt/notesSlides/notesSlide13.xml><?xml version="1.0" encoding="utf-8"?>
-<p:notes xmlns:a="http://schemas.openxmlformats.org/drawingml/2006/main" xmlns:p="http://schemas.openxmlformats.org/presentationml/2006/main" xmlns:r="http://schemas.openxmlformats.org/officeDocument/2006/relationships">
-  <p:cSld>
-    <p:spTree>
-      <p:nvGrpSpPr>
-        <p:cNvPr id="1" name=""/>
-        <p:cNvGrpSpPr/>
-        <p:nvPr/>
-      </p:nvGrpSpPr>
-      <p:grpSpPr>
-        <a:xfrm>
-          <a:off x="0" y="0"/>
-          <a:ext cx="0" cy="0"/>
-          <a:chOff x="0" y="0"/>
-          <a:chExt cx="0" cy="0"/>
-        </a:xfrm>
-      </p:grpSpPr>
-      <p:sp>
-        <p:nvSpPr>
-          <p:cNvPr id="2" name="Slide Image Placeholder 1"/>
-          <p:cNvSpPr>
-            <a:spLocks noGrp="1"/>
-          </p:cNvSpPr>
-          <p:nvPr>
-            <p:ph type="sldImg" idx="2"/>
-          </p:nvPr>
-        </p:nvSpPr>
-        <p:spPr/>
-      </p:sp>
-      <p:sp>
-        <p:nvSpPr>
-          <p:cNvPr id="3" name="Notes Placeholder 2"/>
-          <p:cNvSpPr>
-            <a:spLocks noGrp="1"/>
-          </p:cNvSpPr>
-          <p:nvPr>
-            <p:ph type="body" idx="3" sz="quarter"/>
-          </p:nvPr>
-        </p:nvSpPr>
-        <p:spPr/>
-        <p:txBody>
-          <a:bodyPr/>
-          <a:lstStyle/>
-          <a:p>
-            <a:r>
-              <a:t>ROADMAP (45 sec)</a:t>
-            </a:r>
-          </a:p>
-          <a:p>
-            <a:r>
-              <a:t>Show bounded near-term milestones — investors fund execution, not dreams.</a:t>
-            </a:r>
-          </a:p>
-          <a:p/>
-          <a:p>
-            <a:r>
-              <a:t>NOW</a:t>
-            </a:r>
-          </a:p>
-          <a:p>
-            <a:r>
-              <a:t>Software scaffold and GTM surface — done.</a:t>
-            </a:r>
-          </a:p>
-          <a:p/>
-          <a:p>
-            <a:r>
-              <a:t>NEXT 90 DAYS (funding-sensitive)</a:t>
-            </a:r>
-          </a:p>
-          <a:p>
-            <a:r>
-              <a:t>MS-S1 MAX validation, golden image, production OTA pipeline — this is what hardware receipt unblocks.</a:t>
-            </a:r>
-          </a:p>
-          <a:p/>
-          <a:p>
-            <a:r>
-              <a:t>H2 2026</a:t>
-            </a:r>
-          </a:p>
-          <a:p>
-            <a:r>
-              <a:t>Customer pilots, Engage demo unit for community use case, publish case studies with real operator ROI.</a:t>
-            </a:r>
-          </a:p>
-          <a:p/>
-          <a:p>
-            <a:r>
-              <a:t>2027+</a:t>
-            </a:r>
-          </a:p>
-          <a:p>
-            <a:r>
-              <a:t>Fleet OTA at scale, partner bridge marketplace, enterprise eno2 policy packs.</a:t>
-            </a:r>
-          </a:p>
-          <a:p/>
-          <a:p>
-            <a:r>
-              <a:t>TRANSITION</a:t>
-            </a:r>
-          </a:p>
-          <a:p>
-            <a:r>
-              <a:t>What we are asking for and how to reach us.</a:t>
-            </a:r>
-          </a:p>
-        </p:txBody>
-      </p:sp>
-      <p:sp>
-        <p:nvSpPr>
-          <p:cNvPr id="4" name="Slide Number Placeholder 3"/>
-          <p:cNvSpPr>
-            <a:spLocks noGrp="1"/>
-          </p:cNvSpPr>
-          <p:nvPr>
-            <p:ph type="sldNum" idx="5" sz="quarter"/>
-          </p:nvPr>
-        </p:nvSpPr>
-        <p:spPr/>
-      </p:sp>
-    </p:spTree>
-  </p:cSld>
-  <p:clrMapOvr>
-    <a:masterClrMapping/>
-  </p:clrMapOvr>
-</p:notes>
-</file>
-
-<file path=ppt/notesSlides/notesSlide14.xml><?xml version="1.0" encoding="utf-8"?>
-<p:notes xmlns:a="http://schemas.openxmlformats.org/drawingml/2006/main" xmlns:p="http://schemas.openxmlformats.org/presentationml/2006/main" xmlns:r="http://schemas.openxmlformats.org/officeDocument/2006/relationships">
-  <p:cSld>
-    <p:spTree>
-      <p:nvGrpSpPr>
-        <p:cNvPr id="1" name=""/>
-        <p:cNvGrpSpPr/>
-        <p:nvPr/>
-      </p:nvGrpSpPr>
-      <p:grpSpPr>
-        <a:xfrm>
-          <a:off x="0" y="0"/>
-          <a:ext cx="0" cy="0"/>
-          <a:chOff x="0" y="0"/>
-          <a:chExt cx="0" cy="0"/>
-        </a:xfrm>
-      </p:grpSpPr>
-      <p:sp>
-        <p:nvSpPr>
-          <p:cNvPr id="2" name="Slide Image Placeholder 1"/>
-          <p:cNvSpPr>
-            <a:spLocks noGrp="1"/>
-          </p:cNvSpPr>
-          <p:nvPr>
-            <p:ph type="sldImg" idx="2"/>
-          </p:nvPr>
-        </p:nvSpPr>
-        <p:spPr/>
-      </p:sp>
-      <p:sp>
-        <p:nvSpPr>
-          <p:cNvPr id="3" name="Notes Placeholder 2"/>
-          <p:cNvSpPr>
-            <a:spLocks noGrp="1"/>
-          </p:cNvSpPr>
-          <p:nvPr>
-            <p:ph type="body" idx="3" sz="quarter"/>
-          </p:nvPr>
-        </p:nvSpPr>
-        <p:spPr/>
-        <p:txBody>
-          <a:bodyPr/>
-          <a:lstStyle/>
-          <a:p>
-            <a:r>
-              <a:t>CLOSE (60 sec)</a:t>
-            </a:r>
-          </a:p>
-          <a:p>
-            <a:r>
-              <a:t>Be direct on use of funds; end with the tagline.</a:t>
-            </a:r>
-          </a:p>
-          <a:p/>
-          <a:p>
-            <a:r>
-              <a:t>USE OF FUNDS</a:t>
-            </a:r>
-          </a:p>
-          <a:p>
-            <a:r>
-              <a:t>• Complete MS-S1 MAX validation on real silicon</a:t>
-            </a:r>
-          </a:p>
-          <a:p>
-            <a:r>
-              <a:t>• Golden image manufacturing run</a:t>
-            </a:r>
-          </a:p>
-          <a:p>
-            <a:r>
-              <a:t>• First one hundred customer units</a:t>
-            </a:r>
-          </a:p>
-          <a:p>
-            <a:r>
-              <a:t>• Production OTA pipeline with signed releases</a:t>
-            </a:r>
-          </a:p>
-          <a:p>
-            <a:r>
-              <a:t>• Field engineer for appliance support and factory flash at scale</a:t>
-            </a:r>
-          </a:p>
-          <a:p/>
-          <a:p>
-            <a:r>
-              <a:t>CONTACT</a:t>
-            </a:r>
-          </a:p>
-          <a:p>
-            <a:r>
-              <a:t>curxor.ai · @curxorai · Stripe checkout live for pre-order</a:t>
-            </a:r>
-          </a:p>
-          <a:p/>
-          <a:p>
-            <a:r>
-              <a:t>CLOSING LINE (pause)</a:t>
-            </a:r>
-          </a:p>
-          <a:p>
-            <a:r>
-              <a:t>"Sovereign metal. Infinite Claws. One invoice."</a:t>
-            </a:r>
-          </a:p>
-          <a:p/>
-          <a:p>
-            <a:r>
-              <a:t>TRANSITION</a:t>
-            </a:r>
-          </a:p>
-          <a:p>
-            <a:r>
-              <a:t>If Q&amp;A gets technical or skeptical, advance to the appendix slide — maturity matrix and legal guardrails.</a:t>
-            </a:r>
-          </a:p>
-        </p:txBody>
-      </p:sp>
-      <p:sp>
-        <p:nvSpPr>
-          <p:cNvPr id="4" name="Slide Number Placeholder 3"/>
-          <p:cNvSpPr>
-            <a:spLocks noGrp="1"/>
-          </p:cNvSpPr>
-          <p:nvPr>
-            <p:ph type="sldNum" idx="5" sz="quarter"/>
-          </p:nvPr>
-        </p:nvSpPr>
-        <p:spPr/>
-      </p:sp>
-    </p:spTree>
-  </p:cSld>
-  <p:clrMapOvr>
-    <a:masterClrMapping/>
-  </p:clrMapOvr>
-</p:notes>
-</file>
-
-<file path=ppt/notesSlides/notesSlide15.xml><?xml version="1.0" encoding="utf-8"?>
-<p:notes xmlns:a="http://schemas.openxmlformats.org/drawingml/2006/main" xmlns:p="http://schemas.openxmlformats.org/presentationml/2006/main" xmlns:r="http://schemas.openxmlformats.org/officeDocument/2006/relationships">
-  <p:cSld>
-    <p:spTree>
-      <p:nvGrpSpPr>
-        <p:cNvPr id="1" name=""/>
-        <p:cNvGrpSpPr/>
-        <p:nvPr/>
-      </p:nvGrpSpPr>
-      <p:grpSpPr>
-        <a:xfrm>
-          <a:off x="0" y="0"/>
-          <a:ext cx="0" cy="0"/>
-          <a:chOff x="0" y="0"/>
-          <a:chExt cx="0" cy="0"/>
-        </a:xfrm>
-      </p:grpSpPr>
-      <p:sp>
-        <p:nvSpPr>
-          <p:cNvPr id="2" name="Slide Image Placeholder 1"/>
-          <p:cNvSpPr>
-            <a:spLocks noGrp="1"/>
-          </p:cNvSpPr>
-          <p:nvPr>
-            <p:ph type="sldImg" idx="2"/>
-          </p:nvPr>
-        </p:nvSpPr>
-        <p:spPr/>
-      </p:sp>
-      <p:sp>
-        <p:nvSpPr>
-          <p:cNvPr id="3" name="Notes Placeholder 2"/>
-          <p:cNvSpPr>
-            <a:spLocks noGrp="1"/>
-          </p:cNvSpPr>
-          <p:nvPr>
-            <p:ph type="body" idx="3" sz="quarter"/>
-          </p:nvPr>
-        </p:nvSpPr>
-        <p:spPr/>
-        <p:txBody>
-          <a:bodyPr/>
-          <a:lstStyle/>
-          <a:p>
-            <a:r>
-              <a:t>APPENDIX / Q&amp;A SLIDE (keep in deck — do not present unless asked)</a:t>
-            </a:r>
-          </a:p>
-          <a:p>
-            <a:r>
-              <a:t>Use this slide when investors ask "what is real today?" or "what are the risks?"</a:t>
-            </a:r>
-          </a:p>
-          <a:p/>
-          <a:p>
-            <a:r>
-              <a:t>MATURITY TABLE — walk row by row</a:t>
-            </a:r>
-          </a:p>
-          <a:p>
-            <a:r>
-              <a:t>• Software scaffold: complete, CI green — this is shipped code, not mockups only.</a:t>
-            </a:r>
-          </a:p>
-          <a:p>
-            <a:r>
-              <a:t>• Flight Command + Claws: rich UI; some workspace data is demo/mock until operator credentials loaded.</a:t>
-            </a:r>
-          </a:p>
-          <a:p>
-            <a:r>
-              <a:t>• Local LLM: code complete; requires Ollama deployed on appliance (Pillar 1).</a:t>
-            </a:r>
-          </a:p>
-          <a:p>
-            <a:r>
-              <a:t>• Digital bridges: Alpaca/X coded; operator supplies digital.env credentials.</a:t>
-            </a:r>
-          </a:p>
-          <a:p>
-            <a:r>
-              <a:t>• Hardware validation: blocked on MS-S1 MAX unit receipt — bounded, schedulable risk.</a:t>
-            </a:r>
-          </a:p>
-          <a:p>
-            <a:r>
-              <a:t>• Golden image / OTA: not done — funded by current raise.</a:t>
-            </a:r>
-          </a:p>
-          <a:p/>
-          <a:p>
-            <a:r>
-              <a:t>DISCLAIMERS (read if financial or trading questions arise)</a:t>
-            </a:r>
-          </a:p>
-          <a:p>
-            <a:r>
-              <a:t>• No guaranteed returns. Capital Claw supports paper and live via Alpaca; outcomes depend on operator strategy.</a:t>
-            </a:r>
-          </a:p>
-          <a:p>
-            <a:r>
-              <a:t>• Creator posts require explicit skill approval — no autonomous posting without operator tap.</a:t>
-            </a:r>
-          </a:p>
-          <a:p>
-            <a:r>
-              <a:t>• Pre-order is live; ship dates tied to hardware validation milestone.</a:t>
-            </a:r>
-          </a:p>
-          <a:p/>
-          <a:p>
-            <a:r>
-              <a:t>COMMON QUESTIONS</a:t>
-            </a:r>
-          </a:p>
-          <a:p>
-            <a:r>
-              <a:t>Q: "Is this just Ollama on a PC?"</a:t>
-            </a:r>
-          </a:p>
-          <a:p>
-            <a:r>
-              <a:t>A: FRE + Forge + mesh kill switch + OTA + eight Claws + bridges — integrated appliance, not a dev kit.</a:t>
-            </a:r>
-          </a:p>
-          <a:p/>
-          <a:p>
-            <a:r>
-              <a:t>Q: "Why pre-order before hardware validation?"</a:t>
-            </a:r>
-          </a:p>
-          <a:p>
-            <a:r>
-              <a:t>A: GTM tests demand; software ships today; validation is the gated milestone we are fundraising to close.</a:t>
-            </a:r>
-          </a:p>
-          <a:p/>
-          <a:p>
-            <a:r>
-              <a:t>Q: "Mock data?"</a:t>
-            </a:r>
-          </a:p>
-          <a:p>
-            <a:r>
-              <a:t>A: UI scaffold is production code; live data requires operator bridge credentials on eno2.</a:t>
-            </a:r>
-          </a:p>
-          <a:p/>
-          <a:p>
-            <a:r>
               <a:t>TIMING</a:t>
             </a:r>
           </a:p>
           <a:p>
             <a:r>
-              <a:t>Main deck: 12–15 min. Appendix: 2–3 min when needed. Total with Q&amp;A: 20–25 min.</a:t>
+              <a:t>Main deck ~10–12 min. Appendix 2–3 min. Q&amp;A to 20–25.</a:t>
             </a:r>
           </a:p>
         </p:txBody>
@@ -1523,76 +911,44 @@
           <a:lstStyle/>
           <a:p>
             <a:r>
-              <a:t>FRAMING (45 sec)</a:t>
-            </a:r>
-          </a:p>
-          <a:p>
-            <a:r>
-              <a:t>Name the pain before the product. Investors and buyers both know AI is expensive — we quantify it.</a:t>
+              <a:t>J-CAL / VELOCITY (45 sec)</a:t>
+            </a:r>
+          </a:p>
+          <a:p>
+            <a:r>
+              <a:t>Specificity beats adjectives.</a:t>
             </a:r>
           </a:p>
           <a:p/>
           <a:p>
             <a:r>
-              <a:t>FOR OPERATORS</a:t>
-            </a:r>
-          </a:p>
-          <a:p>
-            <a:r>
-              <a:t>• Algo traders, creators, outbound teams: $500+/mo is conservative for serious agent use.</a:t>
-            </a:r>
-          </a:p>
-          <a:p>
-            <a:r>
-              <a:t>• Every prompt, playbook, and strategy sent to OpenAI/Anthropic is alpha leaving the building.</a:t>
-            </a:r>
-          </a:p>
-          <a:p>
-            <a:r>
-              <a:t>• Layer on CRM, content tools, trading SaaS — margin compression with zero sovereignty.</a:t>
+              <a:t>ARC</a:t>
+            </a:r>
+          </a:p>
+          <a:p>
+            <a:r>
+              <a:t>• Jun 18 public commitment → Jun 19 build start.</a:t>
+            </a:r>
+          </a:p>
+          <a:p>
+            <a:r>
+              <a:t>• MS-S1 is Act I validation metal — product is CurXor box + CurXor OS.</a:t>
+            </a:r>
+          </a:p>
+          <a:p>
+            <a:r>
+              <a:t>• Do not claim SpaceX/Cursor partnership.</a:t>
             </a:r>
           </a:p>
           <a:p/>
           <a:p>
             <a:r>
-              <a:t>FOR THE MARKET</a:t>
-            </a:r>
-          </a:p>
-          <a:p>
-            <a:r>
-              <a:t>• 126 TOPS on a desk is new — MS-S1 MAX class hardware is finally here.</a:t>
-            </a:r>
-          </a:p>
-          <a:p>
-            <a:r>
-              <a:t>• Yet buyers still default to cloud agents because integration is hard.</a:t>
-            </a:r>
-          </a:p>
-          <a:p>
-            <a:r>
-              <a:t>• DIY Ollama-in-a-box is not an agent fleet: no FRE, no Forge, no mesh kill switch, no OTA.</a:t>
-            </a:r>
-          </a:p>
-          <a:p/>
-          <a:p>
-            <a:r>
-              <a:t>OBJECTION PREP</a:t>
-            </a:r>
-          </a:p>
-          <a:p>
-            <a:r>
-              <a:t>"If local models are good enough now, why not just run Ollama?" — Because operators need employees, not a chat window. CurXor ships the full stack.</a:t>
-            </a:r>
-          </a:p>
-          <a:p/>
-          <a:p>
-            <a:r>
-              <a:t>TRANSITION</a:t>
-            </a:r>
-          </a:p>
-          <a:p>
-            <a:r>
-              <a:t>CurXor is the appliance answer — not SaaS, not a science project.</a:t>
+              <a:t>OFFER</a:t>
+            </a:r>
+          </a:p>
+          <a:p>
+            <a:r>
+              <a:t>Inception reel (~90s) for async; live box for truth.</a:t>
             </a:r>
           </a:p>
         </p:txBody>
@@ -1662,75 +1018,28 @@
           <a:lstStyle/>
           <a:p>
             <a:r>
-              <a:t>PRODUCT DEFINITION (60 sec)</a:t>
-            </a:r>
-          </a:p>
-          <a:p>
-            <a:r>
-              <a:t>CurXor OS is pre-integrated software on fixed hardware — an appliance, not a dev kit.</a:t>
+              <a:t>PROBLEM (45 sec)</a:t>
+            </a:r>
+          </a:p>
+          <a:p>
+            <a:r>
+              <a:t>Grammar gap is a symptom — lead holistic: want more AI, told to use it, cannot set up or stay on.</a:t>
             </a:r>
           </a:p>
           <a:p/>
           <a:p>
             <a:r>
-              <a:t>FOUR PILLARS (briefly — do not get lost in engineering)</a:t>
-            </a:r>
-          </a:p>
-          <a:p>
-            <a:r>
-              <a:t>• Pillar 1 Compute: Ollama/vLLM bound to 127.0.0.1 — rejected if not localhost.</a:t>
-            </a:r>
-          </a:p>
-          <a:p>
-            <a:r>
-              <a:t>• Pillar 2 Engine: vision → inference → motor_out / digital_out pipeline.</a:t>
-            </a:r>
-          </a:p>
-          <a:p>
-            <a:r>
-              <a:t>• Pillar 3 Mesh: ZMQ broker on eno2; Alpaca and X bridges for trades and posts only there.</a:t>
-            </a:r>
-          </a:p>
-          <a:p>
-            <a:r>
-              <a:t>• Pillar 4 Flight Command: FRE provisioning, eight Claws, Forge, SSE telemetry, dashboard.</a:t>
-            </a:r>
-          </a:p>
-          <a:p/>
-          <a:p>
-            <a:r>
-              <a:t>FOUR CUSTOMER PROMISES (these are the slide headlines investors remember)</a:t>
-            </a:r>
-          </a:p>
-          <a:p>
-            <a:r>
-              <a:t>1. Local LLM — inference never leaves the box.</a:t>
-            </a:r>
-          </a:p>
-          <a:p>
-            <a:r>
-              <a:t>2. Digital employees — eight OOTB Claws plus The Forge factory.</a:t>
-            </a:r>
-          </a:p>
-          <a:p>
-            <a:r>
-              <a:t>3. Kill switch — eno1 is command plane; eno2 is egress; pull the cable, agents stop outbound.</a:t>
-            </a:r>
-          </a:p>
-          <a:p>
-            <a:r>
-              <a:t>4. Create-to-Earn — natural language → forged Claw → earning on metal in one session.</a:t>
-            </a:r>
-          </a:p>
-          <a:p/>
-          <a:p>
-            <a:r>
-              <a:t>TRANSITION</a:t>
-            </a:r>
-          </a:p>
-          <a:p>
-            <a:r>
-              <a:t>We ship this as two repos today — appliance plus GTM — with one customer promise.</a:t>
+              <a:t>MARKET FAILURES</a:t>
+            </a:r>
+          </a:p>
+          <a:p>
+            <a:r>
+              <a:t>Cloud rent and DIY are both product-shape failures.</a:t>
+            </a:r>
+          </a:p>
+          <a:p>
+            <a:r>
+              <a:t>Wedge: appliance that closes chat → always-on team without assembly.</a:t>
             </a:r>
           </a:p>
         </p:txBody>
@@ -1800,82 +1109,33 @@
           <a:lstStyle/>
           <a:p>
             <a:r>
-              <a:t>TRACTION HONESTY (45 sec — credibility slide)</a:t>
-            </a:r>
-          </a:p>
-          <a:p>
-            <a:r>
-              <a:t>This slide builds trust. Do not oversell hardware readiness.</a:t>
+              <a:t>PRODUCT (60 sec)</a:t>
+            </a:r>
+          </a:p>
+          <a:p>
+            <a:r>
+              <a:t>Say "CurXor box" first — MS-S1 is validation, not brand.</a:t>
             </a:r>
           </a:p>
           <a:p/>
           <a:p>
             <a:r>
-              <a:t>CURXOR-OS</a:t>
-            </a:r>
-          </a:p>
-          <a:p>
-            <a:r>
-              <a:t>• Installs to /opt/curxor/ under systemd target.</a:t>
-            </a:r>
-          </a:p>
-          <a:p>
-            <a:r>
-              <a:t>• v0.9.1 stable — agent runtime, unified comms, Build Plane BP4, ~176 smoke + ~40 user flows in qa:local.</a:t>
-            </a:r>
-          </a:p>
-          <a:p>
-            <a:r>
-              <a:t>• Four pillars wired: compute, engine, mesh, dashboard.</a:t>
-            </a:r>
-          </a:p>
-          <a:p/>
-          <a:p>
-            <a:r>
-              <a:t>STOREFRONT</a:t>
-            </a:r>
-          </a:p>
-          <a:p>
-            <a:r>
-              <a:t>• curxor.ai live with Stripe pre-order and Resend email capture.</a:t>
-            </a:r>
-          </a:p>
-          <a:p>
-            <a:r>
-              <a:t>• Claw catalog synced from appliance source of truth (ootb-apps.ts).</a:t>
-            </a:r>
-          </a:p>
-          <a:p/>
-          <a:p>
-            <a:r>
-              <a:t>GUARDRAIL (say explicitly)</a:t>
-            </a:r>
-          </a:p>
-          <a:p>
-            <a:r>
-              <a:t>Software scaffold is complete. MS-S1 MAX on-device ROCm/UMA validation and golden image freeze are the current gates — we are blocked on hardware receipt, not on engineering vapor.</a:t>
-            </a:r>
-          </a:p>
-          <a:p/>
-          <a:p>
-            <a:r>
-              <a:t>WHY THIS MATTERS TO INVESTORS</a:t>
-            </a:r>
-          </a:p>
-          <a:p>
-            <a:r>
-              <a:t>We are not asking you to fund a slide deck. The GTM surface is live; the software ships; the risk is manufacturing validation, which is bounded and schedulable.</a:t>
-            </a:r>
-          </a:p>
-          <a:p/>
-          <a:p>
-            <a:r>
-              <a:t>TRANSITION</a:t>
-            </a:r>
-          </a:p>
-          <a:p>
-            <a:r>
-              <a:t>The crown jewel of the product story is The Forge.</a:t>
+              <a:t>DEPTH</a:t>
+            </a:r>
+          </a:p>
+          <a:p>
+            <a:r>
+              <a:t>Flagship: Capital / Creator / Work + Forge.</a:t>
+            </a:r>
+          </a:p>
+          <a:p>
+            <a:r>
+              <a:t>Five other Claws: honest Coming Soon.</a:t>
+            </a:r>
+          </a:p>
+          <a:p>
+            <a:r>
+              <a:t>Forge + Cafe are moat — not the cold sell alone.</a:t>
             </a:r>
           </a:p>
         </p:txBody>
@@ -1945,71 +1205,44 @@
           <a:lstStyle/>
           <a:p>
             <a:r>
-              <a:t>DEMO MOMENT (60 sec — show enthusiasm here)</a:t>
-            </a:r>
-          </a:p>
-          <a:p>
-            <a:r>
-              <a:t>The Forge is where CurXor stops being hardware and becomes a platform loop.</a:t>
+              <a:t>PROOF (60 sec)</a:t>
+            </a:r>
+          </a:p>
+          <a:p>
+            <a:r>
+              <a:t>Lead with metrics cite card. Four pillars are systemd on box.</a:t>
             </a:r>
           </a:p>
           <a:p/>
           <a:p>
             <a:r>
-              <a:t>WALK THE FOUR STEPS</a:t>
-            </a:r>
-          </a:p>
-          <a:p>
-            <a:r>
-              <a:t>1. Operator describes intent — niche, workflow, even a photo or camera feed for vision context.</a:t>
-            </a:r>
-          </a:p>
-          <a:p>
-            <a:r>
-              <a:t>2. Local LLM recommends model stack tier based on UMA budget — no cloud provisioning API.</a:t>
-            </a:r>
-          </a:p>
-          <a:p>
-            <a:r>
-              <a:t>3. One tap writes Claw profile and applies to the engine — deploy on-box.</a:t>
-            </a:r>
-          </a:p>
-          <a:p>
-            <a:r>
-              <a:t>4. Claw runs 24/7: trade, create, outreach, arbitrage — whatever was forged.</a:t>
+              <a:t>HONESTY</a:t>
+            </a:r>
+          </a:p>
+          <a:p>
+            <a:r>
+              <a:t>• Paper Capital on camera — say out loud.</a:t>
+            </a:r>
+          </a:p>
+          <a:p>
+            <a:r>
+              <a:t>• Live broker/social fills founder-keyed / G4 — do not claim fleet fills.</a:t>
+            </a:r>
+          </a:p>
+          <a:p>
+            <a:r>
+              <a:t>• Offer LAN demo: Flight Command :3080.</a:t>
             </a:r>
           </a:p>
           <a:p/>
           <a:p>
             <a:r>
-              <a:t>CREATE-TO-EARN NARRATIVE</a:t>
-            </a:r>
-          </a:p>
-          <a:p>
-            <a:r>
-              <a:t>This is our viral mechanic: every buyer can mint specialized digital employees without per-token billing. Agencies white-label this later; indie hackers mint capital and creator Claws day one.</a:t>
-            </a:r>
-          </a:p>
-          <a:p/>
-          <a:p>
-            <a:r>
-              <a:t>COMPETITIVE ANGLE</a:t>
-            </a:r>
-          </a:p>
-          <a:p>
-            <a:r>
-              <a:t>No competitor ships a natural-language Claw factory on localhost with immediate engine deployment.</a:t>
-            </a:r>
-          </a:p>
-          <a:p/>
-          <a:p>
-            <a:r>
-              <a:t>TRANSITION</a:t>
-            </a:r>
-          </a:p>
-          <a:p>
-            <a:r>
-              <a:t>Forge mints custom Claws; we also ship ten digital employees out of the box.</a:t>
+              <a:t>VISUALS</a:t>
+            </a:r>
+          </a:p>
+          <a:p>
+            <a:r>
+              <a:t>07-system-health-toks.png · 01-home.png · inception reel.</a:t>
             </a:r>
           </a:p>
         </p:txBody>
@@ -2079,90 +1312,34 @@
           <a:lstStyle/>
           <a:p>
             <a:r>
-              <a:t>PRODUCT DEPTH (60 sec — table optional in live demo)</a:t>
-            </a:r>
-          </a:p>
-          <a:p>
-            <a:r>
-              <a:t>Read the roster confidently; investors should hear "complete suite," not "ten random apps."</a:t>
+              <a:t>COMPETITIVE (45 sec)</a:t>
+            </a:r>
+          </a:p>
+          <a:p>
+            <a:r>
+              <a:t>No named competitors on the leave-behind.</a:t>
             </a:r>
           </a:p>
           <a:p/>
           <a:p>
             <a:r>
-              <a:t>THE ROSTER</a:t>
-            </a:r>
-          </a:p>
-          <a:p>
-            <a:r>
-              <a:t>• The Forge — mint custom Claws</a:t>
-            </a:r>
-          </a:p>
-          <a:p>
-            <a:r>
-              <a:t>• Capital Claw — algo rules, Alpaca bridge on eno2</a:t>
-            </a:r>
-          </a:p>
-          <a:p>
-            <a:r>
-              <a:t>• Creator Claw — content pipeline, X bridge on eno2</a:t>
-            </a:r>
-          </a:p>
-          <a:p>
-            <a:r>
-              <a:t>• Outreach Claw — outbound sequences, CRM-style desk</a:t>
-            </a:r>
-          </a:p>
-          <a:p>
-            <a:r>
-              <a:t>• Arbitrage Claw — margin watch, fulfillment ops</a:t>
-            </a:r>
-          </a:p>
-          <a:p>
-            <a:r>
-              <a:t>• Signal Claw — The Neural Link: humanoid preview; device hub for glance, VR, robot, home, fleet</a:t>
-            </a:r>
-          </a:p>
-          <a:p>
-            <a:r>
-              <a:t>• Swarm Claw — robotaxi fleet preview from sovereign metal</a:t>
-            </a:r>
-          </a:p>
-          <a:p>
-            <a:r>
-              <a:t>• Engage Claw — community and DM engagement demos</a:t>
-            </a:r>
-          </a:p>
-          <a:p>
-            <a:r>
-              <a:t>• Vital Claw — wearables, labs, longevity protocol</a:t>
-            </a:r>
-          </a:p>
-          <a:p>
-            <a:r>
-              <a:t>• Kin Claw — household profiles, devices, personalities</a:t>
+              <a:t>CULTURAL THREAT</a:t>
+            </a:r>
+          </a:p>
+          <a:p>
+            <a:r>
+              <a:t>Free agent runtime + Mac Mini — counter is complete OS + desks + kill switch + 200 hours back.</a:t>
             </a:r>
           </a:p>
           <a:p/>
           <a:p>
             <a:r>
-              <a:t>SECURITY MODEL (important for enterprise)</a:t>
-            </a:r>
-          </a:p>
-          <a:p>
-            <a:r>
-              <a:t>Each workspace is an agent console. Trades and posts require an explicit skill tap — the LLM does not call the internet directly. Outbound is skill → mesh → Python bridge on eno2 only.</a:t>
-            </a:r>
-          </a:p>
-          <a:p/>
-          <a:p>
-            <a:r>
-              <a:t>TRANSITION</a:t>
-            </a:r>
-          </a:p>
-          <a:p>
-            <a:r>
-              <a:t>This product architecture is deliberately sovereign — two network ports, two trust zones.</a:t>
+              <a:t>NEVER</a:t>
+            </a:r>
+          </a:p>
+          <a:p>
+            <a:r>
+              <a:t>Abacus · partnership cosplay · breadth theater · "100x" without box data.</a:t>
             </a:r>
           </a:p>
         </p:txBody>
@@ -2232,92 +1409,39 @@
           <a:lstStyle/>
           <a:p>
             <a:r>
-              <a:t>ARCHITECTURE (60 sec — draw on whiteboard if room allows)</a:t>
-            </a:r>
-          </a:p>
-          <a:p>
-            <a:r>
-              <a:t>This slide separates CurXor from "AI PC" marketing.</a:t>
+              <a:t>ECONOMICS (60 sec)</a:t>
+            </a:r>
+          </a:p>
+          <a:p>
+            <a:r>
+              <a:t>Hardware is the anchor. Software evolves OTA.</a:t>
             </a:r>
           </a:p>
           <a:p/>
           <a:p>
             <a:r>
-              <a:t>ENO1 — COMMAND PLANE</a:t>
-            </a:r>
-          </a:p>
-          <a:p>
-            <a:r>
-              <a:t>• Flight Command dashboard on 10.0.0.1:3080</a:t>
-            </a:r>
-          </a:p>
-          <a:p>
-            <a:r>
-              <a:t>• Captive portal for operators</a:t>
-            </a:r>
-          </a:p>
-          <a:p>
-            <a:r>
-              <a:t>• FRE, eight Claws, Forge, SSE telemetry</a:t>
-            </a:r>
-          </a:p>
-          <a:p>
-            <a:r>
-              <a:t>• Local LLM client talks to Pillar 1 on localhost only</a:t>
+              <a:t>REJECT</a:t>
+            </a:r>
+          </a:p>
+          <a:p>
+            <a:r>
+              <a:t>Mandatory monthly tiers as the default story (assistant-box pattern).</a:t>
             </a:r>
           </a:p>
           <a:p/>
           <a:p>
             <a:r>
-              <a:t>ENO2 — EGRESS PLANE</a:t>
-            </a:r>
-          </a:p>
-          <a:p>
-            <a:r>
-              <a:t>• ZMQ mesh broker</a:t>
-            </a:r>
-          </a:p>
-          <a:p>
-            <a:r>
-              <a:t>• Digital bridges: Alpaca (trades), X (posts)</a:t>
-            </a:r>
-          </a:p>
-          <a:p>
-            <a:r>
-              <a:t>• Physical kill switch story: unplug eno2, outbound agents stop</a:t>
-            </a:r>
-          </a:p>
-          <a:p/>
-          <a:p>
-            <a:r>
-              <a:t>MESH PORTS</a:t>
-            </a:r>
-          </a:p>
-          <a:p>
-            <a:r>
-              <a:t>Vision 9100/9101, Motor 9200/9201 — robotics path remains in stack for Engage demos and future hardware Claws.</a:t>
-            </a:r>
-          </a:p>
-          <a:p/>
-          <a:p>
-            <a:r>
-              <a:t>ENTERPRISE HOOK</a:t>
-            </a:r>
-          </a:p>
-          <a:p>
-            <a:r>
-              <a:t>CISOs understand two-port segmentation better than "we promise not to exfiltrate."</a:t>
-            </a:r>
-          </a:p>
-          <a:p/>
-          <a:p>
-            <a:r>
-              <a:t>TRANSITION</a:t>
-            </a:r>
-          </a:p>
-          <a:p>
-            <a:r>
-              <a:t>All of this runs on a specific hardware powerhouse — not generic x86.</a:t>
+              <a:t>ACTS</a:t>
+            </a:r>
+          </a:p>
+          <a:p>
+            <a:r>
+              <a:t>Act I validates on appliance metal.</a:t>
+            </a:r>
+          </a:p>
+          <a:p>
+            <a:r>
+              <a:t>Act II CurXor-designed hardware post-investment.</a:t>
             </a:r>
           </a:p>
         </p:txBody>
@@ -2387,81 +1511,22 @@
           <a:lstStyle/>
           <a:p>
             <a:r>
-              <a:t>HARDWARE (45 sec)</a:t>
-            </a:r>
-          </a:p>
-          <a:p>
-            <a:r>
-              <a:t>Anchor the software story in silicon.</a:t>
-            </a:r>
-          </a:p>
-          <a:p/>
-          <a:p>
-            <a:r>
-              <a:t>SPECS (hit the numbers)</a:t>
-            </a:r>
-          </a:p>
-          <a:p>
-            <a:r>
-              <a:t>• Ryzen AI Max+ 395 — CPU + NPU integrated</a:t>
-            </a:r>
-          </a:p>
-          <a:p>
-            <a:r>
-              <a:t>• 126 TOPS NPU inference — desk-scale, 24/7 workloads</a:t>
-            </a:r>
-          </a:p>
-          <a:p>
-            <a:r>
-              <a:t>• 64 GB unified memory — shared CPU/GPU/NPU pool</a:t>
-            </a:r>
-          </a:p>
-          <a:p>
-            <a:r>
-              <a:t>• ~48 GB GPU heap via BIOS carve — primary lever for large models</a:t>
-            </a:r>
-          </a:p>
-          <a:p>
-            <a:r>
-              <a:t>• Dual 10GbE — eno1/eno2 separation at wire speed</a:t>
-            </a:r>
-          </a:p>
-          <a:p>
-            <a:r>
-              <a:t>• ROCm gfx1151 — validated path pending unit receipt</a:t>
-            </a:r>
-          </a:p>
-          <a:p/>
-          <a:p>
-            <a:r>
-              <a:t>POSITIONING LINE</a:t>
-            </a:r>
-          </a:p>
-          <a:p>
-            <a:r>
-              <a:t>"Not a PC — a money printer with local inference." Use if audience is operator-heavy; soften for institutional investors.</a:t>
-            </a:r>
-          </a:p>
-          <a:p/>
-          <a:p>
-            <a:r>
-              <a:t>BIOS STORY</a:t>
-            </a:r>
-          </a:p>
-          <a:p>
-            <a:r>
-              <a:t>UMA carve-out is how we run 7B–35B models alongside the agent engine without cloud burst pricing.</a:t>
-            </a:r>
-          </a:p>
-          <a:p/>
-          <a:p>
-            <a:r>
-              <a:t>TRANSITION</a:t>
-            </a:r>
-          </a:p>
-          <a:p>
-            <a:r>
-              <a:t>Hardware is $3,999 once — let me walk the business model.</a:t>
+              <a:t>HONESTY (45 sec)</a:t>
+            </a:r>
+          </a:p>
+          <a:p>
+            <a:r>
+              <a:t>Pre-revenue and solo founder are facts — say them.</a:t>
+            </a:r>
+          </a:p>
+          <a:p>
+            <a:r>
+              <a:t>Agent-assisted build explains velocity without inventing a team slide.</a:t>
+            </a:r>
+          </a:p>
+          <a:p>
+            <a:r>
+              <a:t>Design partners during the raise — not fake logos.</a:t>
             </a:r>
           </a:p>
         </p:txBody>
@@ -2531,81 +1596,22 @@
           <a:lstStyle/>
           <a:p>
             <a:r>
-              <a:t>ECONOMICS (60 sec)</a:t>
-            </a:r>
-          </a:p>
-          <a:p>
-            <a:r>
-              <a:t>Lead with hardware revenue clarity; expansion is optional upside.</a:t>
-            </a:r>
-          </a:p>
-          <a:p/>
-          <a:p>
-            <a:r>
-              <a:t>HARDWARE NOW</a:t>
-            </a:r>
-          </a:p>
-          <a:p>
-            <a:r>
-              <a:t>• $3,999 one-time — bundle includes CurXor OS flash path</a:t>
-            </a:r>
-          </a:p>
-          <a:p>
-            <a:r>
-              <a:t>• Stripe pre-order live on curxor.ai</a:t>
-            </a:r>
-          </a:p>
-          <a:p>
-            <a:r>
-              <a:t>• No required monthly API fee — this is the wedge vs ChatGPT Teams + agent SaaS stacks</a:t>
-            </a:r>
-          </a:p>
-          <a:p/>
-          <a:p>
-            <a:r>
-              <a:t>EXPANSION (do not over-weight — mention as optionality)</a:t>
-            </a:r>
-          </a:p>
-          <a:p>
-            <a:r>
-              <a:t>• OTA channel subscriptions</a:t>
-            </a:r>
-          </a:p>
-          <a:p>
-            <a:r>
-              <a:t>• Partner bridge marketplace (new egress integrations)</a:t>
-            </a:r>
-          </a:p>
-          <a:p>
-            <a:r>
-              <a:t>• Enterprise fleet with eno2 policy packs</a:t>
-            </a:r>
-          </a:p>
-          <a:p>
-            <a:r>
-              <a:t>• White-label Forge for agencies</a:t>
-            </a:r>
-          </a:p>
-          <a:p/>
-          <a:p>
-            <a:r>
-              <a:t>WEDGE MATH</a:t>
-            </a:r>
-          </a:p>
-          <a:p>
-            <a:r>
-              <a:t>Power users burning $500+/mo in tokens = $6k+/yr. At $3,999 hardware, payback under eight months on API savings alone — before counting SaaS CRM/scheduler replacements.</a:t>
-            </a:r>
-          </a:p>
-          <a:p/>
-          <a:p>
-            <a:r>
-              <a:t>TRANSITION</a:t>
-            </a:r>
-          </a:p>
-          <a:p>
-            <a:r>
-              <a:t>Who buys this first? Five personas we are already messaging on the storefront.</a:t>
+              <a:t>FUNDS (45 sec)</a:t>
+            </a:r>
+          </a:p>
+          <a:p>
+            <a:r>
+              <a:t>Headcount cap is intentional.</a:t>
+            </a:r>
+          </a:p>
+          <a:p>
+            <a:r>
+              <a:t>30% hardware exploration = dream-state custom box after proof, not before.</a:t>
+            </a:r>
+          </a:p>
+          <a:p>
+            <a:r>
+              <a:t>GTM buys G4 smiles and design partners — not paid vanity growth.</a:t>
             </a:r>
           </a:p>
         </p:txBody>
@@ -5786,7 +4792,7 @@
                 </a:solidFill>
                 <a:latin typeface="Consolas"/>
               </a:rPr>
-              <a:t>1 / 15</a:t>
+              <a:t>1 / 11</a:t>
             </a:r>
           </a:p>
         </p:txBody>
@@ -5899,7 +4905,7 @@
                 </a:solidFill>
                 <a:latin typeface="Segoe UI"/>
               </a:rPr>
-              <a:t>Mint Autonomous Employees on Bare Metal.</a:t>
+              <a:t>A sovereign AI system on your desk — with digital employees</a:t>
             </a:r>
           </a:p>
         </p:txBody>
@@ -5912,7 +4918,7 @@
         </p:nvSpPr>
         <p:spPr>
           <a:xfrm>
-            <a:off x="731520" y="3337560"/>
+            <a:off x="731520" y="3721608"/>
             <a:ext cx="10058400" cy="320040"/>
           </a:xfrm>
           <a:prstGeom prst="rect">
@@ -5934,7 +4940,7 @@
                 </a:solidFill>
                 <a:latin typeface="Consolas"/>
               </a:rPr>
-              <a:t>$3,999 once  ·  $0/mo API  ·  126 TOPS  ·  64 GB UMA</a:t>
+              <a:t>$3M seed SAFE · 18 mo · 5 people max</a:t>
             </a:r>
           </a:p>
         </p:txBody>
@@ -5969,7 +4975,7 @@
                 </a:solidFill>
                 <a:latin typeface="Consolas"/>
               </a:rPr>
-              <a:t>ChatGPT bills per token. CurXor bills once.</a:t>
+              <a:t>$3,999 once · $0/mo operate-plane API · proof-ready · pre-revenue</a:t>
             </a:r>
           </a:p>
         </p:txBody>
@@ -6004,7 +5010,7 @@
                 </a:solidFill>
                 <a:latin typeface="Segoe UI"/>
               </a:rPr>
-              <a:t>ChatGPT bills per token. CurXor bills once.</a:t>
+              <a:t>$3,999 once · $0/mo operate-plane API · proof-ready · pre-revenue</a:t>
             </a:r>
           </a:p>
         </p:txBody>
@@ -6039,7 +5045,7 @@
                 </a:solidFill>
                 <a:latin typeface="Consolas"/>
               </a:rPr>
-              <a:t>v0.9.1 · June 2026 · Sovereign Agent Appliance</a:t>
+              <a:t>v1.1.0 · July 2026 · Sovereign Agent Appliance</a:t>
             </a:r>
           </a:p>
         </p:txBody>
@@ -6237,7 +5243,7 @@
                 </a:solidFill>
                 <a:latin typeface="Consolas"/>
               </a:rPr>
-              <a:t>10 / 15</a:t>
+              <a:t>10 / 11</a:t>
             </a:r>
           </a:p>
         </p:txBody>
@@ -6315,7 +5321,7 @@
                 </a:solidFill>
                 <a:latin typeface="Segoe UI"/>
               </a:rPr>
-              <a:t>Target buyers</a:t>
+              <a:t>Ask + links</a:t>
             </a:r>
           </a:p>
         </p:txBody>
@@ -6397,7 +5403,7 @@
                 </a:solidFill>
                 <a:latin typeface="Segoe UI"/>
               </a:rPr>
-              <a:t>Algo trader → Capital Claw on localhost (API fees + leakage)</a:t>
+              <a:t>Warm intros · live box demo on LAN :3080</a:t>
             </a:r>
           </a:p>
           <a:p>
@@ -6413,7 +5419,7 @@
                 </a:solidFill>
                 <a:latin typeface="Segoe UI"/>
               </a:rPr>
-              <a:t>Creator / indie hacker → Creator Claw, $0/mo inference</a:t>
+              <a:t>curxor.ai · /signal · press · inception reel · investor proof</a:t>
             </a:r>
           </a:p>
           <a:p>
@@ -6429,7 +5435,7 @@
                 </a:solidFill>
                 <a:latin typeface="Segoe UI"/>
               </a:rPr>
-              <a:t>Outbound / agency → Outreach Claw on-box</a:t>
+              <a:t>Essay + origin thread · ankur@curxor.ai · @ankurmisra</a:t>
             </a:r>
           </a:p>
           <a:p>
@@ -6439,13 +5445,13 @@
               </a:spcAft>
             </a:pPr>
             <a:r>
-              <a:rPr sz="1900">
+              <a:rPr sz="1000">
                 <a:solidFill>
                   <a:srgbClr val="D2D2DC"/>
                 </a:solidFill>
                 <a:latin typeface="Segoe UI"/>
               </a:rPr>
-              <a:t>E-com / arbitrage → Arbitrage Claw</a:t>
+              <a:t> </a:t>
             </a:r>
           </a:p>
           <a:p>
@@ -6461,7 +5467,7 @@
                 </a:solidFill>
                 <a:latin typeface="Segoe UI"/>
               </a:rPr>
-              <a:t>Sovereignty-maximalist → pull eno2 = kill switch</a:t>
+              <a:t>No cold spam · no public raise posts · sovereign metal · one invoice</a:t>
             </a:r>
           </a:p>
         </p:txBody>
@@ -6659,1679 +5665,7 @@
                 </a:solidFill>
                 <a:latin typeface="Consolas"/>
               </a:rPr>
-              <a:t>11 / 15</a:t>
-            </a:r>
-          </a:p>
-        </p:txBody>
-      </p:sp>
-      <p:sp>
-        <p:nvSpPr>
-          <p:cNvPr id="7" name="Rectangle 6"/>
-          <p:cNvSpPr/>
-          <p:nvPr/>
-        </p:nvSpPr>
-        <p:spPr>
-          <a:xfrm>
-            <a:off x="502920" y="6327648"/>
-            <a:ext cx="11155680" cy="13716"/>
-          </a:xfrm>
-          <a:prstGeom prst="rect">
-            <a:avLst/>
-          </a:prstGeom>
-          <a:solidFill>
-            <a:srgbClr val="32323A"/>
-          </a:solidFill>
-          <a:ln>
-            <a:noFill/>
-          </a:ln>
-        </p:spPr>
-        <p:style>
-          <a:lnRef idx="1">
-            <a:schemeClr val="accent1"/>
-          </a:lnRef>
-          <a:fillRef idx="3">
-            <a:schemeClr val="accent1"/>
-          </a:fillRef>
-          <a:effectRef idx="2">
-            <a:schemeClr val="accent1"/>
-          </a:effectRef>
-          <a:fontRef idx="minor">
-            <a:schemeClr val="lt1"/>
-          </a:fontRef>
-        </p:style>
-        <p:txBody>
-          <a:bodyPr rtlCol="0" anchor="ctr"/>
-          <a:lstStyle/>
-          <a:p>
-            <a:pPr algn="ctr"/>
-          </a:p>
-        </p:txBody>
-      </p:sp>
-      <p:sp>
-        <p:nvSpPr>
-          <p:cNvPr id="8" name="TextBox 7"/>
-          <p:cNvSpPr txBox="1"/>
-          <p:nvPr/>
-        </p:nvSpPr>
-        <p:spPr>
-          <a:xfrm>
-            <a:off x="502920" y="658368"/>
-            <a:ext cx="10972800" cy="685800"/>
-          </a:xfrm>
-          <a:prstGeom prst="rect">
-            <a:avLst/>
-          </a:prstGeom>
-          <a:noFill/>
-        </p:spPr>
-        <p:txBody>
-          <a:bodyPr wrap="square" anchor="t">
-            <a:spAutoFit/>
-          </a:bodyPr>
-          <a:lstStyle/>
-          <a:p>
-            <a:pPr algn="l"/>
-            <a:r>
-              <a:rPr sz="3000" b="1">
-                <a:solidFill>
-                  <a:srgbClr val="FFFFFF"/>
-                </a:solidFill>
-                <a:latin typeface="Segoe UI"/>
-              </a:rPr>
-              <a:t>Why CurXor wins</a:t>
-            </a:r>
-          </a:p>
-        </p:txBody>
-      </p:sp>
-      <p:sp>
-        <p:nvSpPr>
-          <p:cNvPr id="9" name="Rectangle 8"/>
-          <p:cNvSpPr/>
-          <p:nvPr/>
-        </p:nvSpPr>
-        <p:spPr>
-          <a:xfrm>
-            <a:off x="502920" y="1261872"/>
-            <a:ext cx="64008" cy="457200"/>
-          </a:xfrm>
-          <a:prstGeom prst="rect">
-            <a:avLst/>
-          </a:prstGeom>
-          <a:solidFill>
-            <a:srgbClr val="BF5AF2"/>
-          </a:solidFill>
-          <a:ln>
-            <a:noFill/>
-          </a:ln>
-        </p:spPr>
-        <p:style>
-          <a:lnRef idx="1">
-            <a:schemeClr val="accent1"/>
-          </a:lnRef>
-          <a:fillRef idx="3">
-            <a:schemeClr val="accent1"/>
-          </a:fillRef>
-          <a:effectRef idx="2">
-            <a:schemeClr val="accent1"/>
-          </a:effectRef>
-          <a:fontRef idx="minor">
-            <a:schemeClr val="lt1"/>
-          </a:fontRef>
-        </p:style>
-        <p:txBody>
-          <a:bodyPr rtlCol="0" anchor="ctr"/>
-          <a:lstStyle/>
-          <a:p>
-            <a:pPr algn="ctr"/>
-          </a:p>
-        </p:txBody>
-      </p:sp>
-      <p:sp>
-        <p:nvSpPr>
-          <p:cNvPr id="10" name="TextBox 9"/>
-          <p:cNvSpPr txBox="1"/>
-          <p:nvPr/>
-        </p:nvSpPr>
-        <p:spPr>
-          <a:xfrm>
-            <a:off x="685800" y="1417320"/>
-            <a:ext cx="10789920" cy="4754880"/>
-          </a:xfrm>
-          <a:prstGeom prst="rect">
-            <a:avLst/>
-          </a:prstGeom>
-          <a:noFill/>
-        </p:spPr>
-        <p:txBody>
-          <a:bodyPr wrap="square">
-            <a:spAutoFit/>
-          </a:bodyPr>
-          <a:lstStyle/>
-          <a:p>
-            <a:pPr>
-              <a:spcAft>
-                <a:spcPts val="600"/>
-              </a:spcAft>
-            </a:pPr>
-            <a:r>
-              <a:rPr sz="1900">
-                <a:solidFill>
-                  <a:srgbClr val="D2D2DC"/>
-                </a:solidFill>
-                <a:latin typeface="Segoe UI"/>
-              </a:rPr>
-              <a:t>vs DIY Ollama box → FRE, Forge, mesh, OTA, bridges</a:t>
-            </a:r>
-          </a:p>
-          <a:p>
-            <a:pPr>
-              <a:spcAft>
-                <a:spcPts val="600"/>
-              </a:spcAft>
-            </a:pPr>
-            <a:r>
-              <a:rPr sz="1900">
-                <a:solidFill>
-                  <a:srgbClr val="D2D2DC"/>
-                </a:solidFill>
-                <a:latin typeface="Segoe UI"/>
-              </a:rPr>
-              <a:t>vs SaaS agents → alpha local; skill → bridge, not LLM → internet</a:t>
-            </a:r>
-          </a:p>
-          <a:p>
-            <a:pPr>
-              <a:spcAft>
-                <a:spcPts val="600"/>
-              </a:spcAft>
-            </a:pPr>
-            <a:r>
-              <a:rPr sz="1900">
-                <a:solidFill>
-                  <a:srgbClr val="D2D2DC"/>
-                </a:solidFill>
-                <a:latin typeface="Segoe UI"/>
-              </a:rPr>
-              <a:t>vs cloud tiers → 126 TOPS desk beats rate limits for 24/7</a:t>
-            </a:r>
-          </a:p>
-          <a:p>
-            <a:pPr>
-              <a:spcAft>
-                <a:spcPts val="600"/>
-              </a:spcAft>
-            </a:pPr>
-            <a:r>
-              <a:rPr sz="1900">
-                <a:solidFill>
-                  <a:srgbClr val="D2D2DC"/>
-                </a:solidFill>
-                <a:latin typeface="Segoe UI"/>
-              </a:rPr>
-              <a:t>vs robotics novelty → Digital Wealth: Claws as employees, ROI language</a:t>
-            </a:r>
-          </a:p>
-          <a:p>
-            <a:pPr>
-              <a:spcAft>
-                <a:spcPts val="600"/>
-              </a:spcAft>
-            </a:pPr>
-            <a:r>
-              <a:rPr sz="1900">
-                <a:solidFill>
-                  <a:srgbClr val="D2D2DC"/>
-                </a:solidFill>
-                <a:latin typeface="Segoe UI"/>
-              </a:rPr>
-              <a:t>vs security slides → two-port architecture + physical kill switch</a:t>
-            </a:r>
-          </a:p>
-        </p:txBody>
-      </p:sp>
-    </p:spTree>
-  </p:cSld>
-  <p:clrMapOvr>
-    <a:masterClrMapping/>
-  </p:clrMapOvr>
-</p:sld>
-</file>
-
-<file path=ppt/slides/slide12.xml><?xml version="1.0" encoding="utf-8"?>
-<p:sld xmlns:a="http://schemas.openxmlformats.org/drawingml/2006/main" xmlns:p="http://schemas.openxmlformats.org/presentationml/2006/main" xmlns:r="http://schemas.openxmlformats.org/officeDocument/2006/relationships">
-  <p:cSld>
-    <p:bg>
-      <p:bgPr>
-        <a:solidFill>
-          <a:srgbClr val="121216"/>
-        </a:solidFill>
-        <a:effectLst/>
-      </p:bgPr>
-    </p:bg>
-    <p:spTree>
-      <p:nvGrpSpPr>
-        <p:cNvPr id="1" name=""/>
-        <p:cNvGrpSpPr/>
-        <p:nvPr/>
-      </p:nvGrpSpPr>
-      <p:grpSpPr/>
-      <p:sp>
-        <p:nvSpPr>
-          <p:cNvPr id="2" name="Rectangle 1"/>
-          <p:cNvSpPr/>
-          <p:nvPr/>
-        </p:nvSpPr>
-        <p:spPr>
-          <a:xfrm>
-            <a:off x="0" y="0"/>
-            <a:ext cx="12191695" cy="54864"/>
-          </a:xfrm>
-          <a:prstGeom prst="rect">
-            <a:avLst/>
-          </a:prstGeom>
-          <a:solidFill>
-            <a:srgbClr val="BF5AF2"/>
-          </a:solidFill>
-          <a:ln>
-            <a:noFill/>
-          </a:ln>
-        </p:spPr>
-        <p:style>
-          <a:lnRef idx="1">
-            <a:schemeClr val="accent1"/>
-          </a:lnRef>
-          <a:fillRef idx="3">
-            <a:schemeClr val="accent1"/>
-          </a:fillRef>
-          <a:effectRef idx="2">
-            <a:schemeClr val="accent1"/>
-          </a:effectRef>
-          <a:fontRef idx="minor">
-            <a:schemeClr val="lt1"/>
-          </a:fontRef>
-        </p:style>
-        <p:txBody>
-          <a:bodyPr rtlCol="0" anchor="ctr"/>
-          <a:lstStyle/>
-          <a:p>
-            <a:pPr algn="ctr"/>
-          </a:p>
-        </p:txBody>
-      </p:sp>
-      <p:pic>
-        <p:nvPicPr>
-          <p:cNvPr id="3" name="Picture 2" descr="curxor-logo-mark.png"/>
-          <p:cNvPicPr>
-            <a:picLocks noChangeAspect="1"/>
-          </p:cNvPicPr>
-          <p:nvPr/>
-        </p:nvPicPr>
-        <p:blipFill>
-          <a:blip r:embed="rId2"/>
-          <a:stretch>
-            <a:fillRect/>
-          </a:stretch>
-        </p:blipFill>
-        <p:spPr>
-          <a:xfrm>
-            <a:off x="502920" y="164592"/>
-            <a:ext cx="384048" cy="384048"/>
-          </a:xfrm>
-          <a:prstGeom prst="rect">
-            <a:avLst/>
-          </a:prstGeom>
-        </p:spPr>
-      </p:pic>
-      <p:sp>
-        <p:nvSpPr>
-          <p:cNvPr id="4" name="TextBox 3"/>
-          <p:cNvSpPr txBox="1"/>
-          <p:nvPr/>
-        </p:nvSpPr>
-        <p:spPr>
-          <a:xfrm>
-            <a:off x="960120" y="146304"/>
-            <a:ext cx="2286000" cy="320040"/>
-          </a:xfrm>
-          <a:prstGeom prst="rect">
-            <a:avLst/>
-          </a:prstGeom>
-          <a:noFill/>
-        </p:spPr>
-        <p:txBody>
-          <a:bodyPr wrap="square" anchor="t">
-            <a:spAutoFit/>
-          </a:bodyPr>
-          <a:lstStyle/>
-          <a:p>
-            <a:pPr algn="l"/>
-            <a:r>
-              <a:rPr sz="1600" b="1">
-                <a:solidFill>
-                  <a:srgbClr val="FFFFFF"/>
-                </a:solidFill>
-                <a:latin typeface="Consolas"/>
-              </a:rPr>
-              <a:t>CurXor</a:t>
-            </a:r>
-          </a:p>
-        </p:txBody>
-      </p:sp>
-      <p:sp>
-        <p:nvSpPr>
-          <p:cNvPr id="5" name="TextBox 4"/>
-          <p:cNvSpPr txBox="1"/>
-          <p:nvPr/>
-        </p:nvSpPr>
-        <p:spPr>
-          <a:xfrm>
-            <a:off x="502920" y="6446520"/>
-            <a:ext cx="3657600" cy="228600"/>
-          </a:xfrm>
-          <a:prstGeom prst="rect">
-            <a:avLst/>
-          </a:prstGeom>
-          <a:noFill/>
-        </p:spPr>
-        <p:txBody>
-          <a:bodyPr wrap="square" anchor="t">
-            <a:spAutoFit/>
-          </a:bodyPr>
-          <a:lstStyle/>
-          <a:p>
-            <a:pPr algn="l"/>
-            <a:r>
-              <a:rPr sz="900" b="0">
-                <a:solidFill>
-                  <a:srgbClr val="8C8C9B"/>
-                </a:solidFill>
-                <a:latin typeface="Consolas"/>
-              </a:rPr>
-              <a:t>curxor.ai</a:t>
-            </a:r>
-          </a:p>
-        </p:txBody>
-      </p:sp>
-      <p:sp>
-        <p:nvSpPr>
-          <p:cNvPr id="6" name="TextBox 5"/>
-          <p:cNvSpPr txBox="1"/>
-          <p:nvPr/>
-        </p:nvSpPr>
-        <p:spPr>
-          <a:xfrm>
-            <a:off x="10515600" y="6446520"/>
-            <a:ext cx="1371600" cy="228600"/>
-          </a:xfrm>
-          <a:prstGeom prst="rect">
-            <a:avLst/>
-          </a:prstGeom>
-          <a:noFill/>
-        </p:spPr>
-        <p:txBody>
-          <a:bodyPr wrap="square" anchor="t">
-            <a:spAutoFit/>
-          </a:bodyPr>
-          <a:lstStyle/>
-          <a:p>
-            <a:pPr algn="r"/>
-            <a:r>
-              <a:rPr sz="900" b="0">
-                <a:solidFill>
-                  <a:srgbClr val="8C8C9B"/>
-                </a:solidFill>
-                <a:latin typeface="Consolas"/>
-              </a:rPr>
-              <a:t>12 / 15</a:t>
-            </a:r>
-          </a:p>
-        </p:txBody>
-      </p:sp>
-      <p:sp>
-        <p:nvSpPr>
-          <p:cNvPr id="7" name="Rectangle 6"/>
-          <p:cNvSpPr/>
-          <p:nvPr/>
-        </p:nvSpPr>
-        <p:spPr>
-          <a:xfrm>
-            <a:off x="502920" y="6327648"/>
-            <a:ext cx="11155680" cy="13716"/>
-          </a:xfrm>
-          <a:prstGeom prst="rect">
-            <a:avLst/>
-          </a:prstGeom>
-          <a:solidFill>
-            <a:srgbClr val="32323A"/>
-          </a:solidFill>
-          <a:ln>
-            <a:noFill/>
-          </a:ln>
-        </p:spPr>
-        <p:style>
-          <a:lnRef idx="1">
-            <a:schemeClr val="accent1"/>
-          </a:lnRef>
-          <a:fillRef idx="3">
-            <a:schemeClr val="accent1"/>
-          </a:fillRef>
-          <a:effectRef idx="2">
-            <a:schemeClr val="accent1"/>
-          </a:effectRef>
-          <a:fontRef idx="minor">
-            <a:schemeClr val="lt1"/>
-          </a:fontRef>
-        </p:style>
-        <p:txBody>
-          <a:bodyPr rtlCol="0" anchor="ctr"/>
-          <a:lstStyle/>
-          <a:p>
-            <a:pPr algn="ctr"/>
-          </a:p>
-        </p:txBody>
-      </p:sp>
-      <p:sp>
-        <p:nvSpPr>
-          <p:cNvPr id="8" name="TextBox 7"/>
-          <p:cNvSpPr txBox="1"/>
-          <p:nvPr/>
-        </p:nvSpPr>
-        <p:spPr>
-          <a:xfrm>
-            <a:off x="502920" y="658368"/>
-            <a:ext cx="10972800" cy="685800"/>
-          </a:xfrm>
-          <a:prstGeom prst="rect">
-            <a:avLst/>
-          </a:prstGeom>
-          <a:noFill/>
-        </p:spPr>
-        <p:txBody>
-          <a:bodyPr wrap="square" anchor="t">
-            <a:spAutoFit/>
-          </a:bodyPr>
-          <a:lstStyle/>
-          <a:p>
-            <a:pPr algn="l"/>
-            <a:r>
-              <a:rPr sz="3000" b="1">
-                <a:solidFill>
-                  <a:srgbClr val="FFFFFF"/>
-                </a:solidFill>
-                <a:latin typeface="Segoe UI"/>
-              </a:rPr>
-              <a:t>Traction &amp; validation</a:t>
-            </a:r>
-          </a:p>
-        </p:txBody>
-      </p:sp>
-      <p:sp>
-        <p:nvSpPr>
-          <p:cNvPr id="9" name="Rectangle 8"/>
-          <p:cNvSpPr/>
-          <p:nvPr/>
-        </p:nvSpPr>
-        <p:spPr>
-          <a:xfrm>
-            <a:off x="502920" y="1261872"/>
-            <a:ext cx="64008" cy="457200"/>
-          </a:xfrm>
-          <a:prstGeom prst="rect">
-            <a:avLst/>
-          </a:prstGeom>
-          <a:solidFill>
-            <a:srgbClr val="BF5AF2"/>
-          </a:solidFill>
-          <a:ln>
-            <a:noFill/>
-          </a:ln>
-        </p:spPr>
-        <p:style>
-          <a:lnRef idx="1">
-            <a:schemeClr val="accent1"/>
-          </a:lnRef>
-          <a:fillRef idx="3">
-            <a:schemeClr val="accent1"/>
-          </a:fillRef>
-          <a:effectRef idx="2">
-            <a:schemeClr val="accent1"/>
-          </a:effectRef>
-          <a:fontRef idx="minor">
-            <a:schemeClr val="lt1"/>
-          </a:fontRef>
-        </p:style>
-        <p:txBody>
-          <a:bodyPr rtlCol="0" anchor="ctr"/>
-          <a:lstStyle/>
-          <a:p>
-            <a:pPr algn="ctr"/>
-          </a:p>
-        </p:txBody>
-      </p:sp>
-      <p:sp>
-        <p:nvSpPr>
-          <p:cNvPr id="10" name="TextBox 9"/>
-          <p:cNvSpPr txBox="1"/>
-          <p:nvPr/>
-        </p:nvSpPr>
-        <p:spPr>
-          <a:xfrm>
-            <a:off x="685800" y="1417320"/>
-            <a:ext cx="10789920" cy="4754880"/>
-          </a:xfrm>
-          <a:prstGeom prst="rect">
-            <a:avLst/>
-          </a:prstGeom>
-          <a:noFill/>
-        </p:spPr>
-        <p:txBody>
-          <a:bodyPr wrap="square">
-            <a:spAutoFit/>
-          </a:bodyPr>
-          <a:lstStyle/>
-          <a:p>
-            <a:pPr>
-              <a:spcAft>
-                <a:spcPts val="600"/>
-              </a:spcAft>
-            </a:pPr>
-            <a:r>
-              <a:rPr sz="1900">
-                <a:solidFill>
-                  <a:srgbClr val="D2D2DC"/>
-                </a:solidFill>
-                <a:latin typeface="Segoe UI"/>
-              </a:rPr>
-              <a:t>Shipped: 4-pillar install · Flight Command · 8 Claws + Forge · local LLM · mesh · OTA · storefront</a:t>
-            </a:r>
-          </a:p>
-          <a:p>
-            <a:pPr>
-              <a:spcAft>
-                <a:spcPts val="600"/>
-              </a:spcAft>
-            </a:pPr>
-            <a:r>
-              <a:rPr sz="1900">
-                <a:solidFill>
-                  <a:srgbClr val="D2D2DC"/>
-                </a:solidFill>
-                <a:latin typeface="Segoe UI"/>
-              </a:rPr>
-              <a:t>Pending: MS-S1 MAX ROCm/UMA · mesh benchmarks · golden image · signed OTA</a:t>
-            </a:r>
-          </a:p>
-          <a:p>
-            <a:pPr>
-              <a:spcAft>
-                <a:spcPts val="600"/>
-              </a:spcAft>
-            </a:pPr>
-            <a:r>
-              <a:rPr sz="1000">
-                <a:solidFill>
-                  <a:srgbClr val="D2D2DC"/>
-                </a:solidFill>
-                <a:latin typeface="Segoe UI"/>
-              </a:rPr>
-              <a:t> </a:t>
-            </a:r>
-          </a:p>
-          <a:p>
-            <a:pPr>
-              <a:spcAft>
-                <a:spcPts val="600"/>
-              </a:spcAft>
-            </a:pPr>
-            <a:r>
-              <a:rPr sz="1900">
-                <a:solidFill>
-                  <a:srgbClr val="D2D2DC"/>
-                </a:solidFill>
-                <a:latin typeface="Segoe UI"/>
-              </a:rPr>
-              <a:t>v0.9.1 · ~216 QA checks · Pre-order live</a:t>
-            </a:r>
-          </a:p>
-        </p:txBody>
-      </p:sp>
-    </p:spTree>
-  </p:cSld>
-  <p:clrMapOvr>
-    <a:masterClrMapping/>
-  </p:clrMapOvr>
-</p:sld>
-</file>
-
-<file path=ppt/slides/slide13.xml><?xml version="1.0" encoding="utf-8"?>
-<p:sld xmlns:a="http://schemas.openxmlformats.org/drawingml/2006/main" xmlns:p="http://schemas.openxmlformats.org/presentationml/2006/main" xmlns:r="http://schemas.openxmlformats.org/officeDocument/2006/relationships">
-  <p:cSld>
-    <p:bg>
-      <p:bgPr>
-        <a:solidFill>
-          <a:srgbClr val="121216"/>
-        </a:solidFill>
-        <a:effectLst/>
-      </p:bgPr>
-    </p:bg>
-    <p:spTree>
-      <p:nvGrpSpPr>
-        <p:cNvPr id="1" name=""/>
-        <p:cNvGrpSpPr/>
-        <p:nvPr/>
-      </p:nvGrpSpPr>
-      <p:grpSpPr/>
-      <p:sp>
-        <p:nvSpPr>
-          <p:cNvPr id="2" name="Rectangle 1"/>
-          <p:cNvSpPr/>
-          <p:nvPr/>
-        </p:nvSpPr>
-        <p:spPr>
-          <a:xfrm>
-            <a:off x="0" y="0"/>
-            <a:ext cx="12191695" cy="54864"/>
-          </a:xfrm>
-          <a:prstGeom prst="rect">
-            <a:avLst/>
-          </a:prstGeom>
-          <a:solidFill>
-            <a:srgbClr val="BF5AF2"/>
-          </a:solidFill>
-          <a:ln>
-            <a:noFill/>
-          </a:ln>
-        </p:spPr>
-        <p:style>
-          <a:lnRef idx="1">
-            <a:schemeClr val="accent1"/>
-          </a:lnRef>
-          <a:fillRef idx="3">
-            <a:schemeClr val="accent1"/>
-          </a:fillRef>
-          <a:effectRef idx="2">
-            <a:schemeClr val="accent1"/>
-          </a:effectRef>
-          <a:fontRef idx="minor">
-            <a:schemeClr val="lt1"/>
-          </a:fontRef>
-        </p:style>
-        <p:txBody>
-          <a:bodyPr rtlCol="0" anchor="ctr"/>
-          <a:lstStyle/>
-          <a:p>
-            <a:pPr algn="ctr"/>
-          </a:p>
-        </p:txBody>
-      </p:sp>
-      <p:pic>
-        <p:nvPicPr>
-          <p:cNvPr id="3" name="Picture 2" descr="curxor-logo-mark.png"/>
-          <p:cNvPicPr>
-            <a:picLocks noChangeAspect="1"/>
-          </p:cNvPicPr>
-          <p:nvPr/>
-        </p:nvPicPr>
-        <p:blipFill>
-          <a:blip r:embed="rId2"/>
-          <a:stretch>
-            <a:fillRect/>
-          </a:stretch>
-        </p:blipFill>
-        <p:spPr>
-          <a:xfrm>
-            <a:off x="502920" y="164592"/>
-            <a:ext cx="384048" cy="384048"/>
-          </a:xfrm>
-          <a:prstGeom prst="rect">
-            <a:avLst/>
-          </a:prstGeom>
-        </p:spPr>
-      </p:pic>
-      <p:sp>
-        <p:nvSpPr>
-          <p:cNvPr id="4" name="TextBox 3"/>
-          <p:cNvSpPr txBox="1"/>
-          <p:nvPr/>
-        </p:nvSpPr>
-        <p:spPr>
-          <a:xfrm>
-            <a:off x="960120" y="146304"/>
-            <a:ext cx="2286000" cy="320040"/>
-          </a:xfrm>
-          <a:prstGeom prst="rect">
-            <a:avLst/>
-          </a:prstGeom>
-          <a:noFill/>
-        </p:spPr>
-        <p:txBody>
-          <a:bodyPr wrap="square" anchor="t">
-            <a:spAutoFit/>
-          </a:bodyPr>
-          <a:lstStyle/>
-          <a:p>
-            <a:pPr algn="l"/>
-            <a:r>
-              <a:rPr sz="1600" b="1">
-                <a:solidFill>
-                  <a:srgbClr val="FFFFFF"/>
-                </a:solidFill>
-                <a:latin typeface="Consolas"/>
-              </a:rPr>
-              <a:t>CurXor</a:t>
-            </a:r>
-          </a:p>
-        </p:txBody>
-      </p:sp>
-      <p:sp>
-        <p:nvSpPr>
-          <p:cNvPr id="5" name="TextBox 4"/>
-          <p:cNvSpPr txBox="1"/>
-          <p:nvPr/>
-        </p:nvSpPr>
-        <p:spPr>
-          <a:xfrm>
-            <a:off x="502920" y="6446520"/>
-            <a:ext cx="3657600" cy="228600"/>
-          </a:xfrm>
-          <a:prstGeom prst="rect">
-            <a:avLst/>
-          </a:prstGeom>
-          <a:noFill/>
-        </p:spPr>
-        <p:txBody>
-          <a:bodyPr wrap="square" anchor="t">
-            <a:spAutoFit/>
-          </a:bodyPr>
-          <a:lstStyle/>
-          <a:p>
-            <a:pPr algn="l"/>
-            <a:r>
-              <a:rPr sz="900" b="0">
-                <a:solidFill>
-                  <a:srgbClr val="8C8C9B"/>
-                </a:solidFill>
-                <a:latin typeface="Consolas"/>
-              </a:rPr>
-              <a:t>curxor.ai</a:t>
-            </a:r>
-          </a:p>
-        </p:txBody>
-      </p:sp>
-      <p:sp>
-        <p:nvSpPr>
-          <p:cNvPr id="6" name="TextBox 5"/>
-          <p:cNvSpPr txBox="1"/>
-          <p:nvPr/>
-        </p:nvSpPr>
-        <p:spPr>
-          <a:xfrm>
-            <a:off x="10515600" y="6446520"/>
-            <a:ext cx="1371600" cy="228600"/>
-          </a:xfrm>
-          <a:prstGeom prst="rect">
-            <a:avLst/>
-          </a:prstGeom>
-          <a:noFill/>
-        </p:spPr>
-        <p:txBody>
-          <a:bodyPr wrap="square" anchor="t">
-            <a:spAutoFit/>
-          </a:bodyPr>
-          <a:lstStyle/>
-          <a:p>
-            <a:pPr algn="r"/>
-            <a:r>
-              <a:rPr sz="900" b="0">
-                <a:solidFill>
-                  <a:srgbClr val="8C8C9B"/>
-                </a:solidFill>
-                <a:latin typeface="Consolas"/>
-              </a:rPr>
-              <a:t>13 / 15</a:t>
-            </a:r>
-          </a:p>
-        </p:txBody>
-      </p:sp>
-      <p:sp>
-        <p:nvSpPr>
-          <p:cNvPr id="7" name="Rectangle 6"/>
-          <p:cNvSpPr/>
-          <p:nvPr/>
-        </p:nvSpPr>
-        <p:spPr>
-          <a:xfrm>
-            <a:off x="502920" y="6327648"/>
-            <a:ext cx="11155680" cy="13716"/>
-          </a:xfrm>
-          <a:prstGeom prst="rect">
-            <a:avLst/>
-          </a:prstGeom>
-          <a:solidFill>
-            <a:srgbClr val="32323A"/>
-          </a:solidFill>
-          <a:ln>
-            <a:noFill/>
-          </a:ln>
-        </p:spPr>
-        <p:style>
-          <a:lnRef idx="1">
-            <a:schemeClr val="accent1"/>
-          </a:lnRef>
-          <a:fillRef idx="3">
-            <a:schemeClr val="accent1"/>
-          </a:fillRef>
-          <a:effectRef idx="2">
-            <a:schemeClr val="accent1"/>
-          </a:effectRef>
-          <a:fontRef idx="minor">
-            <a:schemeClr val="lt1"/>
-          </a:fontRef>
-        </p:style>
-        <p:txBody>
-          <a:bodyPr rtlCol="0" anchor="ctr"/>
-          <a:lstStyle/>
-          <a:p>
-            <a:pPr algn="ctr"/>
-          </a:p>
-        </p:txBody>
-      </p:sp>
-      <p:sp>
-        <p:nvSpPr>
-          <p:cNvPr id="8" name="TextBox 7"/>
-          <p:cNvSpPr txBox="1"/>
-          <p:nvPr/>
-        </p:nvSpPr>
-        <p:spPr>
-          <a:xfrm>
-            <a:off x="502920" y="658368"/>
-            <a:ext cx="10972800" cy="685800"/>
-          </a:xfrm>
-          <a:prstGeom prst="rect">
-            <a:avLst/>
-          </a:prstGeom>
-          <a:noFill/>
-        </p:spPr>
-        <p:txBody>
-          <a:bodyPr wrap="square" anchor="t">
-            <a:spAutoFit/>
-          </a:bodyPr>
-          <a:lstStyle/>
-          <a:p>
-            <a:pPr algn="l"/>
-            <a:r>
-              <a:rPr sz="3000" b="1">
-                <a:solidFill>
-                  <a:srgbClr val="FFFFFF"/>
-                </a:solidFill>
-                <a:latin typeface="Segoe UI"/>
-              </a:rPr>
-              <a:t>Roadmap</a:t>
-            </a:r>
-          </a:p>
-        </p:txBody>
-      </p:sp>
-      <p:sp>
-        <p:nvSpPr>
-          <p:cNvPr id="9" name="Rectangle 8"/>
-          <p:cNvSpPr/>
-          <p:nvPr/>
-        </p:nvSpPr>
-        <p:spPr>
-          <a:xfrm>
-            <a:off x="502920" y="1261872"/>
-            <a:ext cx="64008" cy="457200"/>
-          </a:xfrm>
-          <a:prstGeom prst="rect">
-            <a:avLst/>
-          </a:prstGeom>
-          <a:solidFill>
-            <a:srgbClr val="BF5AF2"/>
-          </a:solidFill>
-          <a:ln>
-            <a:noFill/>
-          </a:ln>
-        </p:spPr>
-        <p:style>
-          <a:lnRef idx="1">
-            <a:schemeClr val="accent1"/>
-          </a:lnRef>
-          <a:fillRef idx="3">
-            <a:schemeClr val="accent1"/>
-          </a:fillRef>
-          <a:effectRef idx="2">
-            <a:schemeClr val="accent1"/>
-          </a:effectRef>
-          <a:fontRef idx="minor">
-            <a:schemeClr val="lt1"/>
-          </a:fontRef>
-        </p:style>
-        <p:txBody>
-          <a:bodyPr rtlCol="0" anchor="ctr"/>
-          <a:lstStyle/>
-          <a:p>
-            <a:pPr algn="ctr"/>
-          </a:p>
-        </p:txBody>
-      </p:sp>
-      <p:sp>
-        <p:nvSpPr>
-          <p:cNvPr id="10" name="TextBox 9"/>
-          <p:cNvSpPr txBox="1"/>
-          <p:nvPr/>
-        </p:nvSpPr>
-        <p:spPr>
-          <a:xfrm>
-            <a:off x="685800" y="1417320"/>
-            <a:ext cx="10789920" cy="4754880"/>
-          </a:xfrm>
-          <a:prstGeom prst="rect">
-            <a:avLst/>
-          </a:prstGeom>
-          <a:noFill/>
-        </p:spPr>
-        <p:txBody>
-          <a:bodyPr wrap="square">
-            <a:spAutoFit/>
-          </a:bodyPr>
-          <a:lstStyle/>
-          <a:p>
-            <a:pPr>
-              <a:spcAft>
-                <a:spcPts val="600"/>
-              </a:spcAft>
-            </a:pPr>
-            <a:r>
-              <a:rPr sz="1900">
-                <a:solidFill>
-                  <a:srgbClr val="D2D2DC"/>
-                </a:solidFill>
-                <a:latin typeface="Segoe UI"/>
-              </a:rPr>
-              <a:t>Now (v0.9.1): agent runtime · unified comms · Build Plane BP4 · ~216 QA · GTM live</a:t>
-            </a:r>
-          </a:p>
-          <a:p>
-            <a:pPr>
-              <a:spcAft>
-                <a:spcPts val="600"/>
-              </a:spcAft>
-            </a:pPr>
-            <a:r>
-              <a:rPr sz="1900">
-                <a:solidFill>
-                  <a:srgbClr val="D2D2DC"/>
-                </a:solidFill>
-                <a:latin typeface="Segoe UI"/>
-              </a:rPr>
-              <a:t>Next 90 days: MS-S1 MAX validation · golden image · production OTA</a:t>
-            </a:r>
-          </a:p>
-          <a:p>
-            <a:pPr>
-              <a:spcAft>
-                <a:spcPts val="600"/>
-              </a:spcAft>
-            </a:pPr>
-            <a:r>
-              <a:rPr sz="1900">
-                <a:solidFill>
-                  <a:srgbClr val="D2D2DC"/>
-                </a:solidFill>
-                <a:latin typeface="Segoe UI"/>
-              </a:rPr>
-              <a:t>H2 2026: customer pilots · Engage demo unit · case studies</a:t>
-            </a:r>
-          </a:p>
-          <a:p>
-            <a:pPr>
-              <a:spcAft>
-                <a:spcPts val="600"/>
-              </a:spcAft>
-            </a:pPr>
-            <a:r>
-              <a:rPr sz="1900">
-                <a:solidFill>
-                  <a:srgbClr val="D2D2DC"/>
-                </a:solidFill>
-                <a:latin typeface="Segoe UI"/>
-              </a:rPr>
-              <a:t>2027+: fleet OTA · partner bridges · enterprise eno2 policies</a:t>
-            </a:r>
-          </a:p>
-        </p:txBody>
-      </p:sp>
-    </p:spTree>
-  </p:cSld>
-  <p:clrMapOvr>
-    <a:masterClrMapping/>
-  </p:clrMapOvr>
-</p:sld>
-</file>
-
-<file path=ppt/slides/slide14.xml><?xml version="1.0" encoding="utf-8"?>
-<p:sld xmlns:a="http://schemas.openxmlformats.org/drawingml/2006/main" xmlns:p="http://schemas.openxmlformats.org/presentationml/2006/main" xmlns:r="http://schemas.openxmlformats.org/officeDocument/2006/relationships">
-  <p:cSld>
-    <p:bg>
-      <p:bgPr>
-        <a:solidFill>
-          <a:srgbClr val="121216"/>
-        </a:solidFill>
-        <a:effectLst/>
-      </p:bgPr>
-    </p:bg>
-    <p:spTree>
-      <p:nvGrpSpPr>
-        <p:cNvPr id="1" name=""/>
-        <p:cNvGrpSpPr/>
-        <p:nvPr/>
-      </p:nvGrpSpPr>
-      <p:grpSpPr/>
-      <p:sp>
-        <p:nvSpPr>
-          <p:cNvPr id="2" name="Rectangle 1"/>
-          <p:cNvSpPr/>
-          <p:nvPr/>
-        </p:nvSpPr>
-        <p:spPr>
-          <a:xfrm>
-            <a:off x="0" y="0"/>
-            <a:ext cx="12191695" cy="54864"/>
-          </a:xfrm>
-          <a:prstGeom prst="rect">
-            <a:avLst/>
-          </a:prstGeom>
-          <a:solidFill>
-            <a:srgbClr val="BF5AF2"/>
-          </a:solidFill>
-          <a:ln>
-            <a:noFill/>
-          </a:ln>
-        </p:spPr>
-        <p:style>
-          <a:lnRef idx="1">
-            <a:schemeClr val="accent1"/>
-          </a:lnRef>
-          <a:fillRef idx="3">
-            <a:schemeClr val="accent1"/>
-          </a:fillRef>
-          <a:effectRef idx="2">
-            <a:schemeClr val="accent1"/>
-          </a:effectRef>
-          <a:fontRef idx="minor">
-            <a:schemeClr val="lt1"/>
-          </a:fontRef>
-        </p:style>
-        <p:txBody>
-          <a:bodyPr rtlCol="0" anchor="ctr"/>
-          <a:lstStyle/>
-          <a:p>
-            <a:pPr algn="ctr"/>
-          </a:p>
-        </p:txBody>
-      </p:sp>
-      <p:pic>
-        <p:nvPicPr>
-          <p:cNvPr id="3" name="Picture 2" descr="curxor-logo-mark.png"/>
-          <p:cNvPicPr>
-            <a:picLocks noChangeAspect="1"/>
-          </p:cNvPicPr>
-          <p:nvPr/>
-        </p:nvPicPr>
-        <p:blipFill>
-          <a:blip r:embed="rId2"/>
-          <a:stretch>
-            <a:fillRect/>
-          </a:stretch>
-        </p:blipFill>
-        <p:spPr>
-          <a:xfrm>
-            <a:off x="502920" y="164592"/>
-            <a:ext cx="384048" cy="384048"/>
-          </a:xfrm>
-          <a:prstGeom prst="rect">
-            <a:avLst/>
-          </a:prstGeom>
-        </p:spPr>
-      </p:pic>
-      <p:sp>
-        <p:nvSpPr>
-          <p:cNvPr id="4" name="TextBox 3"/>
-          <p:cNvSpPr txBox="1"/>
-          <p:nvPr/>
-        </p:nvSpPr>
-        <p:spPr>
-          <a:xfrm>
-            <a:off x="960120" y="146304"/>
-            <a:ext cx="2286000" cy="320040"/>
-          </a:xfrm>
-          <a:prstGeom prst="rect">
-            <a:avLst/>
-          </a:prstGeom>
-          <a:noFill/>
-        </p:spPr>
-        <p:txBody>
-          <a:bodyPr wrap="square" anchor="t">
-            <a:spAutoFit/>
-          </a:bodyPr>
-          <a:lstStyle/>
-          <a:p>
-            <a:pPr algn="l"/>
-            <a:r>
-              <a:rPr sz="1600" b="1">
-                <a:solidFill>
-                  <a:srgbClr val="FFFFFF"/>
-                </a:solidFill>
-                <a:latin typeface="Consolas"/>
-              </a:rPr>
-              <a:t>CurXor</a:t>
-            </a:r>
-          </a:p>
-        </p:txBody>
-      </p:sp>
-      <p:sp>
-        <p:nvSpPr>
-          <p:cNvPr id="5" name="TextBox 4"/>
-          <p:cNvSpPr txBox="1"/>
-          <p:nvPr/>
-        </p:nvSpPr>
-        <p:spPr>
-          <a:xfrm>
-            <a:off x="502920" y="6446520"/>
-            <a:ext cx="3657600" cy="228600"/>
-          </a:xfrm>
-          <a:prstGeom prst="rect">
-            <a:avLst/>
-          </a:prstGeom>
-          <a:noFill/>
-        </p:spPr>
-        <p:txBody>
-          <a:bodyPr wrap="square" anchor="t">
-            <a:spAutoFit/>
-          </a:bodyPr>
-          <a:lstStyle/>
-          <a:p>
-            <a:pPr algn="l"/>
-            <a:r>
-              <a:rPr sz="900" b="0">
-                <a:solidFill>
-                  <a:srgbClr val="8C8C9B"/>
-                </a:solidFill>
-                <a:latin typeface="Consolas"/>
-              </a:rPr>
-              <a:t>curxor.ai</a:t>
-            </a:r>
-          </a:p>
-        </p:txBody>
-      </p:sp>
-      <p:sp>
-        <p:nvSpPr>
-          <p:cNvPr id="6" name="TextBox 5"/>
-          <p:cNvSpPr txBox="1"/>
-          <p:nvPr/>
-        </p:nvSpPr>
-        <p:spPr>
-          <a:xfrm>
-            <a:off x="10515600" y="6446520"/>
-            <a:ext cx="1371600" cy="228600"/>
-          </a:xfrm>
-          <a:prstGeom prst="rect">
-            <a:avLst/>
-          </a:prstGeom>
-          <a:noFill/>
-        </p:spPr>
-        <p:txBody>
-          <a:bodyPr wrap="square" anchor="t">
-            <a:spAutoFit/>
-          </a:bodyPr>
-          <a:lstStyle/>
-          <a:p>
-            <a:pPr algn="r"/>
-            <a:r>
-              <a:rPr sz="900" b="0">
-                <a:solidFill>
-                  <a:srgbClr val="8C8C9B"/>
-                </a:solidFill>
-                <a:latin typeface="Consolas"/>
-              </a:rPr>
-              <a:t>14 / 15</a:t>
-            </a:r>
-          </a:p>
-        </p:txBody>
-      </p:sp>
-      <p:sp>
-        <p:nvSpPr>
-          <p:cNvPr id="7" name="Rectangle 6"/>
-          <p:cNvSpPr/>
-          <p:nvPr/>
-        </p:nvSpPr>
-        <p:spPr>
-          <a:xfrm>
-            <a:off x="502920" y="6327648"/>
-            <a:ext cx="11155680" cy="13716"/>
-          </a:xfrm>
-          <a:prstGeom prst="rect">
-            <a:avLst/>
-          </a:prstGeom>
-          <a:solidFill>
-            <a:srgbClr val="32323A"/>
-          </a:solidFill>
-          <a:ln>
-            <a:noFill/>
-          </a:ln>
-        </p:spPr>
-        <p:style>
-          <a:lnRef idx="1">
-            <a:schemeClr val="accent1"/>
-          </a:lnRef>
-          <a:fillRef idx="3">
-            <a:schemeClr val="accent1"/>
-          </a:fillRef>
-          <a:effectRef idx="2">
-            <a:schemeClr val="accent1"/>
-          </a:effectRef>
-          <a:fontRef idx="minor">
-            <a:schemeClr val="lt1"/>
-          </a:fontRef>
-        </p:style>
-        <p:txBody>
-          <a:bodyPr rtlCol="0" anchor="ctr"/>
-          <a:lstStyle/>
-          <a:p>
-            <a:pPr algn="ctr"/>
-          </a:p>
-        </p:txBody>
-      </p:sp>
-      <p:sp>
-        <p:nvSpPr>
-          <p:cNvPr id="8" name="TextBox 7"/>
-          <p:cNvSpPr txBox="1"/>
-          <p:nvPr/>
-        </p:nvSpPr>
-        <p:spPr>
-          <a:xfrm>
-            <a:off x="502920" y="658368"/>
-            <a:ext cx="10972800" cy="685800"/>
-          </a:xfrm>
-          <a:prstGeom prst="rect">
-            <a:avLst/>
-          </a:prstGeom>
-          <a:noFill/>
-        </p:spPr>
-        <p:txBody>
-          <a:bodyPr wrap="square" anchor="t">
-            <a:spAutoFit/>
-          </a:bodyPr>
-          <a:lstStyle/>
-          <a:p>
-            <a:pPr algn="l"/>
-            <a:r>
-              <a:rPr sz="3000" b="1">
-                <a:solidFill>
-                  <a:srgbClr val="FFFFFF"/>
-                </a:solidFill>
-                <a:latin typeface="Segoe UI"/>
-              </a:rPr>
-              <a:t>The ask</a:t>
-            </a:r>
-          </a:p>
-        </p:txBody>
-      </p:sp>
-      <p:sp>
-        <p:nvSpPr>
-          <p:cNvPr id="9" name="Rectangle 8"/>
-          <p:cNvSpPr/>
-          <p:nvPr/>
-        </p:nvSpPr>
-        <p:spPr>
-          <a:xfrm>
-            <a:off x="502920" y="1261872"/>
-            <a:ext cx="64008" cy="457200"/>
-          </a:xfrm>
-          <a:prstGeom prst="rect">
-            <a:avLst/>
-          </a:prstGeom>
-          <a:solidFill>
-            <a:srgbClr val="BF5AF2"/>
-          </a:solidFill>
-          <a:ln>
-            <a:noFill/>
-          </a:ln>
-        </p:spPr>
-        <p:style>
-          <a:lnRef idx="1">
-            <a:schemeClr val="accent1"/>
-          </a:lnRef>
-          <a:fillRef idx="3">
-            <a:schemeClr val="accent1"/>
-          </a:fillRef>
-          <a:effectRef idx="2">
-            <a:schemeClr val="accent1"/>
-          </a:effectRef>
-          <a:fontRef idx="minor">
-            <a:schemeClr val="lt1"/>
-          </a:fontRef>
-        </p:style>
-        <p:txBody>
-          <a:bodyPr rtlCol="0" anchor="ctr"/>
-          <a:lstStyle/>
-          <a:p>
-            <a:pPr algn="ctr"/>
-          </a:p>
-        </p:txBody>
-      </p:sp>
-      <p:sp>
-        <p:nvSpPr>
-          <p:cNvPr id="10" name="TextBox 9"/>
-          <p:cNvSpPr txBox="1"/>
-          <p:nvPr/>
-        </p:nvSpPr>
-        <p:spPr>
-          <a:xfrm>
-            <a:off x="685800" y="1417320"/>
-            <a:ext cx="10789920" cy="4754880"/>
-          </a:xfrm>
-          <a:prstGeom prst="rect">
-            <a:avLst/>
-          </a:prstGeom>
-          <a:noFill/>
-        </p:spPr>
-        <p:txBody>
-          <a:bodyPr wrap="square">
-            <a:spAutoFit/>
-          </a:bodyPr>
-          <a:lstStyle/>
-          <a:p>
-            <a:pPr>
-              <a:spcAft>
-                <a:spcPts val="600"/>
-              </a:spcAft>
-            </a:pPr>
-            <a:r>
-              <a:rPr sz="1900">
-                <a:solidFill>
-                  <a:srgbClr val="D2D2DC"/>
-                </a:solidFill>
-                <a:latin typeface="Segoe UI"/>
-              </a:rPr>
-              <a:t>Fund: MS-S1 MAX validation · golden image run · first 100 units · production OTA</a:t>
-            </a:r>
-          </a:p>
-          <a:p>
-            <a:pPr>
-              <a:spcAft>
-                <a:spcPts val="600"/>
-              </a:spcAft>
-            </a:pPr>
-            <a:r>
-              <a:rPr sz="1900">
-                <a:solidFill>
-                  <a:srgbClr val="D2D2DC"/>
-                </a:solidFill>
-                <a:latin typeface="Segoe UI"/>
-              </a:rPr>
-              <a:t>Hire: field engineer for appliance support + factory flash at scale</a:t>
-            </a:r>
-          </a:p>
-          <a:p>
-            <a:pPr>
-              <a:spcAft>
-                <a:spcPts val="600"/>
-              </a:spcAft>
-            </a:pPr>
-            <a:r>
-              <a:rPr sz="1000">
-                <a:solidFill>
-                  <a:srgbClr val="D2D2DC"/>
-                </a:solidFill>
-                <a:latin typeface="Segoe UI"/>
-              </a:rPr>
-              <a:t> </a:t>
-            </a:r>
-          </a:p>
-          <a:p>
-            <a:pPr>
-              <a:spcAft>
-                <a:spcPts val="600"/>
-              </a:spcAft>
-            </a:pPr>
-            <a:r>
-              <a:rPr sz="1900">
-                <a:solidFill>
-                  <a:srgbClr val="D2D2DC"/>
-                </a:solidFill>
-                <a:latin typeface="Segoe UI"/>
-              </a:rPr>
-              <a:t>curxor.ai · @curxorai · Stripe pre-order on site</a:t>
-            </a:r>
-          </a:p>
-          <a:p>
-            <a:pPr>
-              <a:spcAft>
-                <a:spcPts val="600"/>
-              </a:spcAft>
-            </a:pPr>
-            <a:r>
-              <a:rPr sz="1000">
-                <a:solidFill>
-                  <a:srgbClr val="D2D2DC"/>
-                </a:solidFill>
-                <a:latin typeface="Segoe UI"/>
-              </a:rPr>
-              <a:t> </a:t>
-            </a:r>
-          </a:p>
-          <a:p>
-            <a:pPr>
-              <a:spcAft>
-                <a:spcPts val="600"/>
-              </a:spcAft>
-            </a:pPr>
-            <a:r>
-              <a:rPr sz="1900">
-                <a:solidFill>
-                  <a:srgbClr val="D2D2DC"/>
-                </a:solidFill>
-                <a:latin typeface="Segoe UI"/>
-              </a:rPr>
-              <a:t>Sovereign metal. Infinite Claws. One invoice.</a:t>
-            </a:r>
-          </a:p>
-        </p:txBody>
-      </p:sp>
-    </p:spTree>
-  </p:cSld>
-  <p:clrMapOvr>
-    <a:masterClrMapping/>
-  </p:clrMapOvr>
-</p:sld>
-</file>
-
-<file path=ppt/slides/slide15.xml><?xml version="1.0" encoding="utf-8"?>
-<p:sld xmlns:a="http://schemas.openxmlformats.org/drawingml/2006/main" xmlns:p="http://schemas.openxmlformats.org/presentationml/2006/main" xmlns:r="http://schemas.openxmlformats.org/officeDocument/2006/relationships">
-  <p:cSld>
-    <p:bg>
-      <p:bgPr>
-        <a:solidFill>
-          <a:srgbClr val="121216"/>
-        </a:solidFill>
-        <a:effectLst/>
-      </p:bgPr>
-    </p:bg>
-    <p:spTree>
-      <p:nvGrpSpPr>
-        <p:cNvPr id="1" name=""/>
-        <p:cNvGrpSpPr/>
-        <p:nvPr/>
-      </p:nvGrpSpPr>
-      <p:grpSpPr/>
-      <p:sp>
-        <p:nvSpPr>
-          <p:cNvPr id="2" name="Rectangle 1"/>
-          <p:cNvSpPr/>
-          <p:nvPr/>
-        </p:nvSpPr>
-        <p:spPr>
-          <a:xfrm>
-            <a:off x="0" y="0"/>
-            <a:ext cx="12191695" cy="54864"/>
-          </a:xfrm>
-          <a:prstGeom prst="rect">
-            <a:avLst/>
-          </a:prstGeom>
-          <a:solidFill>
-            <a:srgbClr val="BF5AF2"/>
-          </a:solidFill>
-          <a:ln>
-            <a:noFill/>
-          </a:ln>
-        </p:spPr>
-        <p:style>
-          <a:lnRef idx="1">
-            <a:schemeClr val="accent1"/>
-          </a:lnRef>
-          <a:fillRef idx="3">
-            <a:schemeClr val="accent1"/>
-          </a:fillRef>
-          <a:effectRef idx="2">
-            <a:schemeClr val="accent1"/>
-          </a:effectRef>
-          <a:fontRef idx="minor">
-            <a:schemeClr val="lt1"/>
-          </a:fontRef>
-        </p:style>
-        <p:txBody>
-          <a:bodyPr rtlCol="0" anchor="ctr"/>
-          <a:lstStyle/>
-          <a:p>
-            <a:pPr algn="ctr"/>
-          </a:p>
-        </p:txBody>
-      </p:sp>
-      <p:pic>
-        <p:nvPicPr>
-          <p:cNvPr id="3" name="Picture 2" descr="curxor-logo-mark.png"/>
-          <p:cNvPicPr>
-            <a:picLocks noChangeAspect="1"/>
-          </p:cNvPicPr>
-          <p:nvPr/>
-        </p:nvPicPr>
-        <p:blipFill>
-          <a:blip r:embed="rId2"/>
-          <a:stretch>
-            <a:fillRect/>
-          </a:stretch>
-        </p:blipFill>
-        <p:spPr>
-          <a:xfrm>
-            <a:off x="502920" y="164592"/>
-            <a:ext cx="384048" cy="384048"/>
-          </a:xfrm>
-          <a:prstGeom prst="rect">
-            <a:avLst/>
-          </a:prstGeom>
-        </p:spPr>
-      </p:pic>
-      <p:sp>
-        <p:nvSpPr>
-          <p:cNvPr id="4" name="TextBox 3"/>
-          <p:cNvSpPr txBox="1"/>
-          <p:nvPr/>
-        </p:nvSpPr>
-        <p:spPr>
-          <a:xfrm>
-            <a:off x="960120" y="146304"/>
-            <a:ext cx="2286000" cy="320040"/>
-          </a:xfrm>
-          <a:prstGeom prst="rect">
-            <a:avLst/>
-          </a:prstGeom>
-          <a:noFill/>
-        </p:spPr>
-        <p:txBody>
-          <a:bodyPr wrap="square" anchor="t">
-            <a:spAutoFit/>
-          </a:bodyPr>
-          <a:lstStyle/>
-          <a:p>
-            <a:pPr algn="l"/>
-            <a:r>
-              <a:rPr sz="1600" b="1">
-                <a:solidFill>
-                  <a:srgbClr val="FFFFFF"/>
-                </a:solidFill>
-                <a:latin typeface="Consolas"/>
-              </a:rPr>
-              <a:t>CurXor</a:t>
-            </a:r>
-          </a:p>
-        </p:txBody>
-      </p:sp>
-      <p:sp>
-        <p:nvSpPr>
-          <p:cNvPr id="5" name="TextBox 4"/>
-          <p:cNvSpPr txBox="1"/>
-          <p:nvPr/>
-        </p:nvSpPr>
-        <p:spPr>
-          <a:xfrm>
-            <a:off x="502920" y="6446520"/>
-            <a:ext cx="3657600" cy="228600"/>
-          </a:xfrm>
-          <a:prstGeom prst="rect">
-            <a:avLst/>
-          </a:prstGeom>
-          <a:noFill/>
-        </p:spPr>
-        <p:txBody>
-          <a:bodyPr wrap="square" anchor="t">
-            <a:spAutoFit/>
-          </a:bodyPr>
-          <a:lstStyle/>
-          <a:p>
-            <a:pPr algn="l"/>
-            <a:r>
-              <a:rPr sz="900" b="0">
-                <a:solidFill>
-                  <a:srgbClr val="8C8C9B"/>
-                </a:solidFill>
-                <a:latin typeface="Consolas"/>
-              </a:rPr>
-              <a:t>curxor.ai</a:t>
-            </a:r>
-          </a:p>
-        </p:txBody>
-      </p:sp>
-      <p:sp>
-        <p:nvSpPr>
-          <p:cNvPr id="6" name="TextBox 5"/>
-          <p:cNvSpPr txBox="1"/>
-          <p:nvPr/>
-        </p:nvSpPr>
-        <p:spPr>
-          <a:xfrm>
-            <a:off x="10515600" y="6446520"/>
-            <a:ext cx="1371600" cy="228600"/>
-          </a:xfrm>
-          <a:prstGeom prst="rect">
-            <a:avLst/>
-          </a:prstGeom>
-          <a:noFill/>
-        </p:spPr>
-        <p:txBody>
-          <a:bodyPr wrap="square" anchor="t">
-            <a:spAutoFit/>
-          </a:bodyPr>
-          <a:lstStyle/>
-          <a:p>
-            <a:pPr algn="r"/>
-            <a:r>
-              <a:rPr sz="900" b="0">
-                <a:solidFill>
-                  <a:srgbClr val="8C8C9B"/>
-                </a:solidFill>
-                <a:latin typeface="Consolas"/>
-              </a:rPr>
-              <a:t>15 / 15</a:t>
+              <a:t>11 / 11</a:t>
             </a:r>
           </a:p>
         </p:txBody>
@@ -8487,7 +5821,7 @@
                           </a:solidFill>
                           <a:latin typeface="Segoe UI"/>
                         </a:rPr>
-                        <a:t>Software v0.9.1</a:t>
+                        <a:t>Software v1.0.3</a:t>
                       </a:r>
                     </a:p>
                   </a:txBody>
@@ -8505,7 +5839,7 @@
                           </a:solidFill>
                           <a:latin typeface="Segoe UI"/>
                         </a:rPr>
-                        <a:t>Agent runtime · ~176 smoke + ~40 user flows</a:t>
+                        <a:t>G1/G2/G3 green · 239 smoke · 40 user flows</a:t>
                       </a:r>
                     </a:p>
                   </a:txBody>
@@ -8525,7 +5859,7 @@
                           </a:solidFill>
                           <a:latin typeface="Segoe UI"/>
                         </a:rPr>
-                        <a:t>Flight Command + 8 Claws + Forge</a:t>
+                        <a:t>Flagship Claws + Forge + Cafe</a:t>
                       </a:r>
                     </a:p>
                   </a:txBody>
@@ -8543,7 +5877,7 @@
                           </a:solidFill>
                           <a:latin typeface="Segoe UI"/>
                         </a:rPr>
-                        <a:t>Rich UI · some mock workspace data</a:t>
+                        <a:t>G3 demo depth · Capital paper on camera</a:t>
                       </a:r>
                     </a:p>
                   </a:txBody>
@@ -8563,7 +5897,7 @@
                           </a:solidFill>
                           <a:latin typeface="Segoe UI"/>
                         </a:rPr>
-                        <a:t>Local LLM (engine + dashboard)</a:t>
+                        <a:t>Local LLM (ROCm on box)</a:t>
                       </a:r>
                     </a:p>
                   </a:txBody>
@@ -8581,7 +5915,7 @@
                           </a:solidFill>
                           <a:latin typeface="Segoe UI"/>
                         </a:rPr>
-                        <a:t>Code complete · needs Ollama on appliance</a:t>
+                        <a:t>qwen3:8b · 38 tok/s · validated Jul 2026</a:t>
                       </a:r>
                     </a:p>
                   </a:txBody>
@@ -8619,7 +5953,7 @@
                           </a:solidFill>
                           <a:latin typeface="Segoe UI"/>
                         </a:rPr>
-                        <a:t>Coded · needs digital.env credentials</a:t>
+                        <a:t>Coded · founder-keyed until Ops Wave 1</a:t>
                       </a:r>
                     </a:p>
                   </a:txBody>
@@ -8639,7 +5973,7 @@
                           </a:solidFill>
                           <a:latin typeface="Segoe UI"/>
                         </a:rPr>
-                        <a:t>MS-S1 MAX hardware validation</a:t>
+                        <a:t>MS-S1 MAX validation</a:t>
                       </a:r>
                     </a:p>
                   </a:txBody>
@@ -8657,7 +5991,7 @@
                           </a:solidFill>
                           <a:latin typeface="Segoe UI"/>
                         </a:rPr>
-                        <a:t>Blocked · unit not received</a:t>
+                        <a:t>Unboxed · G1–G3 closed · Act I proof plane</a:t>
                       </a:r>
                     </a:p>
                   </a:txBody>
@@ -8677,7 +6011,7 @@
                           </a:solidFill>
                           <a:latin typeface="Segoe UI"/>
                         </a:rPr>
-                        <a:t>Golden image / production OTA</a:t>
+                        <a:t>Custom CurXor hardware</a:t>
                       </a:r>
                     </a:p>
                   </a:txBody>
@@ -8695,7 +6029,7 @@
                           </a:solidFill>
                           <a:latin typeface="Segoe UI"/>
                         </a:rPr>
-                        <a:t>Not done</a:t>
+                        <a:t>Act II · post-raise</a:t>
                       </a:r>
                     </a:p>
                   </a:txBody>
@@ -8841,7 +6175,7 @@
                 </a:solidFill>
                 <a:latin typeface="Segoe UI"/>
               </a:rPr>
-              <a:t>• Paper trading available; live trades via Alpaca on eno2 only when configured.</a:t>
+              <a:t>• Paper trading on camera; live trades via Alpaca on eno2 only when configured.</a:t>
             </a:r>
           </a:p>
         </p:txBody>
@@ -9039,7 +6373,7 @@
                 </a:solidFill>
                 <a:latin typeface="Consolas"/>
               </a:rPr>
-              <a:t>2 / 15</a:t>
+              <a:t>2 / 11</a:t>
             </a:r>
           </a:p>
         </p:txBody>
@@ -9117,7 +6451,7 @@
                 </a:solidFill>
                 <a:latin typeface="Segoe UI"/>
               </a:rPr>
-              <a:t>The cloud tax on autonomous work</a:t>
+              <a:t>Founder story — 20 days</a:t>
             </a:r>
           </a:p>
         </p:txBody>
@@ -9199,7 +6533,7 @@
                 </a:solidFill>
                 <a:latin typeface="Segoe UI"/>
               </a:rPr>
-              <a:t>Operators pay $500+/mo in API tokens — and leak strategy to cloud LLMs.</a:t>
+              <a:t>Jun 18 — named CurXor in public · origin thread</a:t>
             </a:r>
           </a:p>
           <a:p>
@@ -9215,7 +6549,7 @@
                 </a:solidFill>
                 <a:latin typeface="Segoe UI"/>
               </a:rPr>
-              <a:t>SaaS stacks (CRM, schedulers, trading wrappers) compress margin without sovereignty.</a:t>
+              <a:t>Jun 19 — first commit · Claw OS on laptop</a:t>
             </a:r>
           </a:p>
           <a:p>
@@ -9225,13 +6559,13 @@
               </a:spcAft>
             </a:pPr>
             <a:r>
-              <a:rPr sz="1000">
+              <a:rPr sz="1900">
                 <a:solidFill>
                   <a:srgbClr val="D2D2DC"/>
                 </a:solidFill>
                 <a:latin typeface="Segoe UI"/>
               </a:rPr>
-              <a:t> </a:t>
+              <a:t>Week 1 — four flagship Claws + Forge + agent runtime</a:t>
             </a:r>
           </a:p>
           <a:p>
@@ -9247,7 +6581,7 @@
                 </a:solidFill>
                 <a:latin typeface="Segoe UI"/>
               </a:rPr>
-              <a:t>Edge NPU hardware is real — but no one ships a complete sovereign agent stack.</a:t>
+              <a:t>Week 2 — validation hardware unboxed · Cafe · Build Plane</a:t>
             </a:r>
           </a:p>
           <a:p>
@@ -9263,7 +6597,39 @@
                 </a:solidFill>
                 <a:latin typeface="Segoe UI"/>
               </a:rPr>
-              <a:t>DIY Linux + Ollama lacks orchestration, egress control, OTA, and operator UX.</a:t>
+              <a:t>Week 3 — v1.0.0→v1.0.3 · G1/G2/G3 · film pack</a:t>
+            </a:r>
+          </a:p>
+          <a:p>
+            <a:pPr>
+              <a:spcAft>
+                <a:spcPts val="600"/>
+              </a:spcAft>
+            </a:pPr>
+            <a:r>
+              <a:rPr sz="1000">
+                <a:solidFill>
+                  <a:srgbClr val="D2D2DC"/>
+                </a:solidFill>
+                <a:latin typeface="Segoe UI"/>
+              </a:rPr>
+              <a:t> </a:t>
+            </a:r>
+          </a:p>
+          <a:p>
+            <a:pPr>
+              <a:spcAft>
+                <a:spcPts val="600"/>
+              </a:spcAft>
+            </a:pPr>
+            <a:r>
+              <a:rPr sz="1900">
+                <a:solidFill>
+                  <a:srgbClr val="D2D2DC"/>
+                </a:solidFill>
+                <a:latin typeface="Segoe UI"/>
+              </a:rPr>
+              <a:t>182 commits · 239 smoke · 38 tok/s on validated metal</a:t>
             </a:r>
           </a:p>
         </p:txBody>
@@ -9461,7 +6827,7 @@
                 </a:solidFill>
                 <a:latin typeface="Consolas"/>
               </a:rPr>
-              <a:t>3 / 15</a:t>
+              <a:t>3 / 11</a:t>
             </a:r>
           </a:p>
         </p:txBody>
@@ -9539,7 +6905,7 @@
                 </a:solidFill>
                 <a:latin typeface="Segoe UI"/>
               </a:rPr>
-              <a:t>CurXor: appliance, not another SaaS</a:t>
+              <a:t>Why now</a:t>
             </a:r>
           </a:p>
         </p:txBody>
@@ -9621,7 +6987,7 @@
                 </a:solidFill>
                 <a:latin typeface="Segoe UI"/>
               </a:rPr>
-              <a:t>Four-pillar edge stack on MINISFORUM MS-S1 MAX:</a:t>
+              <a:t>Aspiration — culture says use AI; operators stall after drafts/polish</a:t>
             </a:r>
           </a:p>
           <a:p>
@@ -9637,7 +7003,7 @@
                 </a:solidFill>
                 <a:latin typeface="Segoe UI"/>
               </a:rPr>
-              <a:t>P1 Compute · P2 Engine · P3 Mesh · P4 Flight Command</a:t>
+              <a:t>Setup — always-on still means repos, keys, scripts, five tabs</a:t>
             </a:r>
           </a:p>
           <a:p>
@@ -9647,13 +7013,13 @@
               </a:spcAft>
             </a:pPr>
             <a:r>
-              <a:rPr sz="1000">
+              <a:rPr sz="1900">
                 <a:solidFill>
                   <a:srgbClr val="D2D2DC"/>
                 </a:solidFill>
                 <a:latin typeface="Segoe UI"/>
               </a:rPr>
-              <a:t> </a:t>
+              <a:t>Product shape — chat rent · cloud agents · home cloud · light boxes</a:t>
             </a:r>
           </a:p>
           <a:p>
@@ -9669,7 +7035,7 @@
                 </a:solidFill>
                 <a:latin typeface="Segoe UI"/>
               </a:rPr>
-              <a:t>Local LLM (127.0.0.1 only) · 8 Claws + The Forge</a:t>
+              <a:t>Nobody ships vertical digital employees OOTB on metal you own</a:t>
             </a:r>
           </a:p>
           <a:p>
@@ -9685,23 +7051,7 @@
                 </a:solidFill>
                 <a:latin typeface="Segoe UI"/>
               </a:rPr>
-              <a:t>Kill switch: eno1 command · eno2 egress · unplug stops agents</a:t>
-            </a:r>
-          </a:p>
-          <a:p>
-            <a:pPr>
-              <a:spcAft>
-                <a:spcPts val="600"/>
-              </a:spcAft>
-            </a:pPr>
-            <a:r>
-              <a:rPr sz="1900">
-                <a:solidFill>
-                  <a:srgbClr val="D2D2DC"/>
-                </a:solidFill>
-                <a:latin typeface="Segoe UI"/>
-              </a:rPr>
-              <a:t>Create-to-Earn: describe a Claw → deploy on-box in one session</a:t>
+              <a:t>Desk-ready compute — local inference on operator-grade UMA is real</a:t>
             </a:r>
           </a:p>
         </p:txBody>
@@ -9899,7 +7249,7 @@
                 </a:solidFill>
                 <a:latin typeface="Consolas"/>
               </a:rPr>
-              <a:t>4 / 15</a:t>
+              <a:t>4 / 11</a:t>
             </a:r>
           </a:p>
         </p:txBody>
@@ -9977,7 +7327,7 @@
                 </a:solidFill>
                 <a:latin typeface="Segoe UI"/>
               </a:rPr>
-              <a:t>Two repos · one promise</a:t>
+              <a:t>What we build</a:t>
             </a:r>
           </a:p>
         </p:txBody>
@@ -10059,7 +7409,7 @@
                 </a:solidFill>
                 <a:latin typeface="Segoe UI"/>
               </a:rPr>
-              <a:t>curxor-os — appliance: /opt/curxor/, systemd, OTA · v0.9.1 · ~216 QA checks</a:t>
+              <a:t>CurXor box + CurXor OS (validated on MS-S1-class metal)</a:t>
             </a:r>
           </a:p>
           <a:p>
@@ -10075,7 +7425,7 @@
                 </a:solidFill>
                 <a:latin typeface="Segoe UI"/>
               </a:rPr>
-              <a:t>curxor storefront — GTM: curxor.ai, Stripe, Resend, synced Claw catalog</a:t>
+              <a:t>Four pillars — compute · engine · mesh · Flight Command</a:t>
             </a:r>
           </a:p>
           <a:p>
@@ -10085,13 +7435,13 @@
               </a:spcAft>
             </a:pPr>
             <a:r>
-              <a:rPr sz="1000">
+              <a:rPr sz="1900">
                 <a:solidFill>
                   <a:srgbClr val="D2D2DC"/>
                 </a:solidFill>
                 <a:latin typeface="Segoe UI"/>
               </a:rPr>
-              <a:t> </a:t>
+              <a:t>Ten Claws — Capital · Creator · Work · Forge · Cafe + honest previews</a:t>
             </a:r>
           </a:p>
           <a:p>
@@ -10107,7 +7457,7 @@
                 </a:solidFill>
                 <a:latin typeface="Segoe UI"/>
               </a:rPr>
-              <a:t>Honest status: software scaffold complete.</a:t>
+              <a:t>Forge — mint custom Claws on-box · Cafe — inter-Claw proof</a:t>
             </a:r>
           </a:p>
           <a:p>
@@ -10123,7 +7473,7 @@
                 </a:solidFill>
                 <a:latin typeface="Segoe UI"/>
               </a:rPr>
-              <a:t>Gating: MS-S1 MAX validation + golden image (hardware receipt pending).</a:t>
+              <a:t>Local cognition · egress you wire and can unplug</a:t>
             </a:r>
           </a:p>
         </p:txBody>
@@ -10321,7 +7671,7 @@
                 </a:solidFill>
                 <a:latin typeface="Consolas"/>
               </a:rPr>
-              <a:t>5 / 15</a:t>
+              <a:t>5 / 11</a:t>
             </a:r>
           </a:p>
         </p:txBody>
@@ -10399,7 +7749,7 @@
                 </a:solidFill>
                 <a:latin typeface="Segoe UI"/>
               </a:rPr>
-              <a:t>The Forge — Create-to-Earn</a:t>
+              <a:t>Stack proof</a:t>
             </a:r>
           </a:p>
         </p:txBody>
@@ -10481,7 +7831,7 @@
                 </a:solidFill>
                 <a:latin typeface="Segoe UI"/>
               </a:rPr>
-              <a:t>1. Describe niche (text, photo, or live vision)</a:t>
+              <a:t>G1 golden path · Jul 1 — on device</a:t>
             </a:r>
           </a:p>
           <a:p>
@@ -10497,7 +7847,7 @@
                 </a:solidFill>
                 <a:latin typeface="Segoe UI"/>
               </a:rPr>
-              <a:t>2. Local LLM recommends stack by UMA budget tier</a:t>
+              <a:t>G2 golden release · v1.0.0–v1.0.3</a:t>
             </a:r>
           </a:p>
           <a:p>
@@ -10513,7 +7863,7 @@
                 </a:solidFill>
                 <a:latin typeface="Segoe UI"/>
               </a:rPr>
-              <a:t>3. One tap forges Claw profile → engine</a:t>
+              <a:t>G3 film pack · Jul 8 — inception · investor proof · desk strips</a:t>
             </a:r>
           </a:p>
           <a:p>
@@ -10529,7 +7879,7 @@
                 </a:solidFill>
                 <a:latin typeface="Segoe UI"/>
               </a:rPr>
-              <a:t>4. Claw earns 24/7 on your metal</a:t>
+              <a:t>239 smoke · qwen3:8b · 38 tok/s · 4.56/64 GB</a:t>
             </a:r>
           </a:p>
           <a:p>
@@ -10539,29 +7889,13 @@
               </a:spcAft>
             </a:pPr>
             <a:r>
-              <a:rPr sz="1000">
+              <a:rPr sz="1900">
                 <a:solidFill>
                   <a:srgbClr val="D2D2DC"/>
                 </a:solidFill>
                 <a:latin typeface="Segoe UI"/>
               </a:rPr>
-              <a:t> </a:t>
-            </a:r>
-          </a:p>
-          <a:p>
-            <a:pPr>
-              <a:spcAft>
-                <a:spcPts val="600"/>
-              </a:spcAft>
-            </a:pPr>
-            <a:r>
-              <a:rPr sz="1900">
-                <a:solidFill>
-                  <a:srgbClr val="D2D2DC"/>
-                </a:solidFill>
-                <a:latin typeface="Segoe UI"/>
-              </a:rPr>
-              <a:t>Viral loop: buyers become operators who mint more Claws.</a:t>
+              <a:t>curxor.ai live — G3 stills · /signal · press kit</a:t>
             </a:r>
           </a:p>
         </p:txBody>
@@ -10759,7 +8093,7 @@
                 </a:solidFill>
                 <a:latin typeface="Consolas"/>
               </a:rPr>
-              <a:t>6 / 15</a:t>
+              <a:t>6 / 11</a:t>
             </a:r>
           </a:p>
         </p:txBody>
@@ -10837,7 +8171,7 @@
                 </a:solidFill>
                 <a:latin typeface="Segoe UI"/>
               </a:rPr>
-              <a:t>Ten Claws — digital employees OOTB</a:t>
+              <a:t>Competition</a:t>
             </a:r>
           </a:p>
         </p:txBody>
@@ -10919,7 +8253,7 @@
                 </a:solidFill>
                 <a:latin typeface="Segoe UI"/>
               </a:rPr>
-              <a:t>The Forge · Capital · Creator · Outreach · Arbitrage</a:t>
+              <a:t>Personal cloud / home server → apps, not vertical outcomes</a:t>
             </a:r>
           </a:p>
           <a:p>
@@ -10935,7 +8269,7 @@
                 </a:solidFill>
                 <a:latin typeface="Segoe UI"/>
               </a:rPr>
-              <a:t>Signal · Swarm · Engage · Vital · Kin</a:t>
+              <a:t>DIY agent kits → 200 hours assembly · no egress product</a:t>
             </a:r>
           </a:p>
           <a:p>
@@ -10945,13 +8279,13 @@
               </a:spcAft>
             </a:pPr>
             <a:r>
-              <a:rPr sz="1000">
+              <a:rPr sz="1900">
                 <a:solidFill>
                   <a:srgbClr val="D2D2DC"/>
                 </a:solidFill>
                 <a:latin typeface="Segoe UI"/>
               </a:rPr>
-              <a:t> </a:t>
+              <a:t>Light assistant appliances → chat/messaging · limited compute</a:t>
             </a:r>
           </a:p>
           <a:p>
@@ -10967,7 +8301,7 @@
                 </a:solidFill>
                 <a:latin typeface="Segoe UI"/>
               </a:rPr>
-              <a:t>Each workspace: chat + skills + activity feed</a:t>
+              <a:t>SaaS / cloud agents → API rent · their retention</a:t>
             </a:r>
           </a:p>
           <a:p>
@@ -10977,13 +8311,29 @@
               </a:spcAft>
             </a:pPr>
             <a:r>
-              <a:rPr sz="1900">
+              <a:rPr sz="1000">
                 <a:solidFill>
                   <a:srgbClr val="D2D2DC"/>
                 </a:solidFill>
                 <a:latin typeface="Segoe UI"/>
               </a:rPr>
-              <a:t>Trades/posts via explicit skill → bridge — LLM never hits internet directly</a:t>
+              <a:t> </a:t>
+            </a:r>
+          </a:p>
+          <a:p>
+            <a:pPr>
+              <a:spcAft>
+                <a:spcPts val="600"/>
+              </a:spcAft>
+            </a:pPr>
+            <a:r>
+              <a:rPr sz="1900">
+                <a:solidFill>
+                  <a:srgbClr val="D2D2DC"/>
+                </a:solidFill>
+                <a:latin typeface="Segoe UI"/>
+              </a:rPr>
+              <a:t>CurXor = operator desk with digital employees + kill switch</a:t>
             </a:r>
           </a:p>
         </p:txBody>
@@ -11181,7 +8531,7 @@
                 </a:solidFill>
                 <a:latin typeface="Consolas"/>
               </a:rPr>
-              <a:t>7 / 15</a:t>
+              <a:t>7 / 11</a:t>
             </a:r>
           </a:p>
         </p:txBody>
@@ -11259,7 +8609,7 @@
                 </a:solidFill>
                 <a:latin typeface="Segoe UI"/>
               </a:rPr>
-              <a:t>Sovereign architecture</a:t>
+              <a:t>Business model — current · evolving</a:t>
             </a:r>
           </a:p>
         </p:txBody>
@@ -11341,7 +8691,7 @@
                 </a:solidFill>
                 <a:latin typeface="Segoe UI"/>
               </a:rPr>
-              <a:t>eno1 (10.0.0.1) — Flight Command :3080 · FRE · Claws · Forge · LLM client</a:t>
+              <a:t>Today: $3,999 once · $0/mo operate API · ten Claws + Forge · BYOK optional</a:t>
             </a:r>
           </a:p>
           <a:p>
@@ -11357,7 +8707,7 @@
                 </a:solidFill>
                 <a:latin typeface="Segoe UI"/>
               </a:rPr>
-              <a:t>P1 Ollama @ 127.0.0.1:11434 · P2 Engine · P4 Dashboard</a:t>
+              <a:t>Pre-order live · pre-revenue by design (proof-first)</a:t>
             </a:r>
           </a:p>
           <a:p>
@@ -11389,7 +8739,7 @@
                 </a:solidFill>
                 <a:latin typeface="Segoe UI"/>
               </a:rPr>
-              <a:t>eno2 (10.77.0.1) — ZMQ mesh · Alpaca + X bridges only</a:t>
+              <a:t>Grows: Standard→Pro 128→Studio · Claw unlocks · Forge mint · additive bridges</a:t>
             </a:r>
           </a:p>
           <a:p>
@@ -11405,39 +8755,7 @@
                 </a:solidFill>
                 <a:latin typeface="Segoe UI"/>
               </a:rPr>
-              <a:t>Pull eno2 cable = kill outbound agents</a:t>
-            </a:r>
-          </a:p>
-          <a:p>
-            <a:pPr>
-              <a:spcAft>
-                <a:spcPts val="600"/>
-              </a:spcAft>
-            </a:pPr>
-            <a:r>
-              <a:rPr sz="1000">
-                <a:solidFill>
-                  <a:srgbClr val="D2D2DC"/>
-                </a:solidFill>
-                <a:latin typeface="Segoe UI"/>
-              </a:rPr>
-              <a:t> </a:t>
-            </a:r>
-          </a:p>
-          <a:p>
-            <a:pPr>
-              <a:spcAft>
-                <a:spcPts val="600"/>
-              </a:spcAft>
-            </a:pPr>
-            <a:r>
-              <a:rPr sz="1900">
-                <a:solidFill>
-                  <a:srgbClr val="D2D2DC"/>
-                </a:solidFill>
-                <a:latin typeface="Segoe UI"/>
-              </a:rPr>
-              <a:t>Vision 9100/9101 · Motor 9200/9201</a:t>
+              <a:t>Hardware anchor · OTA on metal you own — not another rent trap</a:t>
             </a:r>
           </a:p>
         </p:txBody>
@@ -11635,7 +8953,7 @@
                 </a:solidFill>
                 <a:latin typeface="Consolas"/>
               </a:rPr>
-              <a:t>8 / 15</a:t>
+              <a:t>8 / 11</a:t>
             </a:r>
           </a:p>
         </p:txBody>
@@ -11713,7 +9031,7 @@
                 </a:solidFill>
                 <a:latin typeface="Segoe UI"/>
               </a:rPr>
-              <a:t>MINISFORUM MS-S1 MAX</a:t>
+              <a:t>PMF honesty</a:t>
             </a:r>
           </a:p>
         </p:txBody>
@@ -11795,7 +9113,7 @@
                 </a:solidFill>
                 <a:latin typeface="Segoe UI"/>
               </a:rPr>
-              <a:t>Ryzen AI Max+ 395 · 126 TOPS NPU · 64 GB UMA</a:t>
+              <a:t>Green — G1/G2/G3 · v1.0.3 · 239 smoke · G3 film pack</a:t>
             </a:r>
           </a:p>
           <a:p>
@@ -11811,7 +9129,7 @@
                 </a:solidFill>
                 <a:latin typeface="Segoe UI"/>
               </a:rPr>
-              <a:t>~48 GB GPU heap (BIOS carve) · Dual 10GbE · ROCm gfx1151</a:t>
+              <a:t>Yellow — Flagship dogfooded · paper/sim on camera · hero Act I live</a:t>
             </a:r>
           </a:p>
           <a:p>
@@ -11821,13 +9139,13 @@
               </a:spcAft>
             </a:pPr>
             <a:r>
-              <a:rPr sz="1000">
+              <a:rPr sz="1900">
                 <a:solidFill>
                   <a:srgbClr val="D2D2DC"/>
                 </a:solidFill>
                 <a:latin typeface="Segoe UI"/>
               </a:rPr>
-              <a:t> </a:t>
+              <a:t>Red — ARR · live fills · custom CurXor hardware (Act II)</a:t>
             </a:r>
           </a:p>
           <a:p>
@@ -11837,13 +9155,29 @@
               </a:spcAft>
             </a:pPr>
             <a:r>
-              <a:rPr sz="1900">
+              <a:rPr sz="1000">
                 <a:solidFill>
                   <a:srgbClr val="D2D2DC"/>
                 </a:solidFill>
                 <a:latin typeface="Segoe UI"/>
               </a:rPr>
-              <a:t>Not a PC — local inference appliance for 7B–35B + agent stack</a:t>
+              <a:t> </a:t>
+            </a:r>
+          </a:p>
+          <a:p>
+            <a:pPr>
+              <a:spcAft>
+                <a:spcPts val="600"/>
+              </a:spcAft>
+            </a:pPr>
+            <a:r>
+              <a:rPr sz="1900">
+                <a:solidFill>
+                  <a:srgbClr val="D2D2DC"/>
+                </a:solidFill>
+                <a:latin typeface="Segoe UI"/>
+              </a:rPr>
+              <a:t>Proof-ready now · traction-ready after G4 external UAT</a:t>
             </a:r>
           </a:p>
         </p:txBody>
@@ -12041,7 +9375,7 @@
                 </a:solidFill>
                 <a:latin typeface="Consolas"/>
               </a:rPr>
-              <a:t>9 / 15</a:t>
+              <a:t>9 / 11</a:t>
             </a:r>
           </a:p>
         </p:txBody>
@@ -12119,7 +9453,7 @@
                 </a:solidFill>
                 <a:latin typeface="Segoe UI"/>
               </a:rPr>
-              <a:t>Business model</a:t>
+              <a:t>Use of funds — $3M seed</a:t>
             </a:r>
           </a:p>
         </p:txBody>
@@ -12201,7 +9535,7 @@
                 </a:solidFill>
                 <a:latin typeface="Segoe UI"/>
               </a:rPr>
-              <a:t>Now: $3,999 MS-S1 MAX bundle · CurXor OS pre-flash · Stripe pre-order live</a:t>
+              <a:t>People (eng · design · ops) — 45%</a:t>
             </a:r>
           </a:p>
           <a:p>
@@ -12211,13 +9545,13 @@
               </a:spcAft>
             </a:pPr>
             <a:r>
-              <a:rPr sz="1000">
+              <a:rPr sz="1900">
                 <a:solidFill>
                   <a:srgbClr val="D2D2DC"/>
                 </a:solidFill>
                 <a:latin typeface="Segoe UI"/>
               </a:rPr>
-              <a:t> </a:t>
+              <a:t>Act II hardware exploration — 30%</a:t>
             </a:r>
           </a:p>
           <a:p>
@@ -12233,7 +9567,7 @@
                 </a:solidFill>
                 <a:latin typeface="Segoe UI"/>
               </a:rPr>
-              <a:t>Future: OTA subscriptions · bridge marketplace · enterprise eno2 policies · white-label Forge</a:t>
+              <a:t>Onboarding / GTM — 10%</a:t>
             </a:r>
           </a:p>
           <a:p>
@@ -12243,13 +9577,13 @@
               </a:spcAft>
             </a:pPr>
             <a:r>
-              <a:rPr sz="1000">
+              <a:rPr sz="1900">
                 <a:solidFill>
                   <a:srgbClr val="D2D2DC"/>
                 </a:solidFill>
                 <a:latin typeface="Segoe UI"/>
               </a:rPr>
-              <a:t> </a:t>
+              <a:t>Ops / buffer — 15%</a:t>
             </a:r>
           </a:p>
           <a:p>
@@ -12259,13 +9593,29 @@
               </a:spcAft>
             </a:pPr>
             <a:r>
-              <a:rPr sz="1900">
+              <a:rPr sz="1000">
                 <a:solidFill>
                   <a:srgbClr val="D2D2DC"/>
                 </a:solidFill>
                 <a:latin typeface="Segoe UI"/>
               </a:rPr>
-              <a:t>Wedge: eliminate $6k+/yr API burn — payback &lt; 8 months for power users</a:t>
+              <a:t> </a:t>
+            </a:r>
+          </a:p>
+          <a:p>
+            <a:pPr>
+              <a:spcAft>
+                <a:spcPts val="600"/>
+              </a:spcAft>
+            </a:pPr>
+            <a:r>
+              <a:rPr sz="1900">
+                <a:solidFill>
+                  <a:srgbClr val="D2D2DC"/>
+                </a:solidFill>
+                <a:latin typeface="Segoe UI"/>
+              </a:rPr>
+              <a:t>18 months · ≤5 people · prove Act I · own metal in Act II</a:t>
             </a:r>
           </a:p>
         </p:txBody>

</xml_diff>

<commit_message>
Commit pitch deck package with refreshed speaker notes and PDF export.
Co-authored-by: Cursor <cursoragent@cursor.com>
</commit_message>
<xml_diff>
--- a/docs/CurXor-Pitch-Deck-Speaker-Notes.pptx
+++ b/docs/CurXor-Pitch-Deck-Speaker-Notes.pptx
@@ -528,12 +528,12 @@
           </a:p>
           <a:p>
             <a:r>
-              <a:t>• Sovereignty investors: owned metal · no API rent · egress boundary · MS-S1 proof.</a:t>
-            </a:r>
-          </a:p>
-          <a:p>
-            <a:r>
-              <a:t>• Product investors: Capital · Creator · Work · Forge · Cafe · desk orchestrator.</a:t>
+              <a:t>• Sovereignty: owned metal · no API rent · operator as principal · MS-S1 proof.</a:t>
+            </a:r>
+          </a:p>
+          <a:p>
+            <a:r>
+              <a:t>• Product: Capital · Creator · Work · Forge · Cafe · desk orchestrator.</a:t>
             </a:r>
           </a:p>
           <a:p/>
@@ -554,7 +554,7 @@
           </a:p>
           <a:p>
             <a:r>
-              <a:t>• Stage: G1/G2/G3 green · pre-revenue · solo founder.</a:t>
+              <a:t>• Stage: proof-ready · working product on real metal · pre-revenue · solo founder.</a:t>
             </a:r>
           </a:p>
           <a:p/>
@@ -772,7 +772,7 @@
           </a:p>
           <a:p>
             <a:r>
-              <a:t>• v1.0.3 appliance green — G1/G2/G3 closed Jul 8.</a:t>
+              <a:t>• v1.0.3 appliance green — golden path + film pack on MS-S1.</a:t>
             </a:r>
           </a:p>
           <a:p>
@@ -782,7 +782,12 @@
           </a:p>
           <a:p>
             <a:r>
-              <a:t>• Bridges: coded; Ops Wave 1 keys founder-gated.</a:t>
+              <a:t>• Bridges: real receipts on founder box — not customer fleet.</a:t>
+            </a:r>
+          </a:p>
+          <a:p>
+            <a:r>
+              <a:t>• Operator golden paths invite-ready; external UAT starting.</a:t>
             </a:r>
           </a:p>
           <a:p>
@@ -937,6 +942,11 @@
           </a:p>
           <a:p>
             <a:r>
+              <a:t>• Jul 9–16 is follow-through (bridges + operator paths) — not a second origin myth.</a:t>
+            </a:r>
+          </a:p>
+          <a:p>
+            <a:r>
               <a:t>• Do not claim SpaceX/Cursor partnership.</a:t>
             </a:r>
           </a:p>
@@ -1042,6 +1052,11 @@
               <a:t>Wedge: appliance that closes chat → always-on team without assembly.</a:t>
             </a:r>
           </a:p>
+          <a:p>
+            <a:r>
+              <a:t>Mission punch if needed: operator as principal of their AI — on metal they own.</a:t>
+            </a:r>
+          </a:p>
         </p:txBody>
       </p:sp>
       <p:sp>
@@ -1210,7 +1225,7 @@
           </a:p>
           <a:p>
             <a:r>
-              <a:t>Lead with metrics cite card. Four pillars are systemd on box.</a:t>
+              <a:t>Lead with plain outcomes + metrics cite card. Four pillars are systemd on box.</a:t>
             </a:r>
           </a:p>
           <a:p/>
@@ -1226,7 +1241,12 @@
           </a:p>
           <a:p>
             <a:r>
-              <a:t>• Live broker/social fills founder-keyed / G4 — do not claim fleet fills.</a:t>
+              <a:t>• Bridges are founder-box truth — do not claim fleet fills or live brokerage.</a:t>
+            </a:r>
+          </a:p>
+          <a:p>
+            <a:r>
+              <a:t>• External operator UAT open — first intros in flight, not closed traction.</a:t>
             </a:r>
           </a:p>
           <a:p>
@@ -1242,7 +1262,7 @@
           </a:p>
           <a:p>
             <a:r>
-              <a:t>07-system-health-toks.png · 01-home.png · inception reel.</a:t>
+              <a:t>07-system-health-toks.png · 01-home.png · inception reel (label OK with URL).</a:t>
             </a:r>
           </a:p>
         </p:txBody>
@@ -1526,7 +1546,12 @@
           </a:p>
           <a:p>
             <a:r>
-              <a:t>Design partners during the raise — not fake logos.</a:t>
+              <a:t>Design-partner remote UAT during the raise — not fake logos.</a:t>
+            </a:r>
+          </a:p>
+          <a:p>
+            <a:r>
+              <a:t>Do not claim Boardy intros as traction — only completed external smiles count.</a:t>
             </a:r>
           </a:p>
         </p:txBody>
@@ -1611,7 +1636,7 @@
           </a:p>
           <a:p>
             <a:r>
-              <a:t>GTM buys G4 smiles and design partners — not paid vanity growth.</a:t>
+              <a:t>GTM buys external operator smiles and design partners — not paid vanity growth.</a:t>
             </a:r>
           </a:p>
         </p:txBody>
@@ -4899,13 +4924,13 @@
           <a:p>
             <a:pPr algn="l"/>
             <a:r>
-              <a:rPr sz="2600" b="0">
+              <a:rPr sz="2200" b="0">
                 <a:solidFill>
                   <a:srgbClr val="BF5AF2"/>
                 </a:solidFill>
                 <a:latin typeface="Segoe UI"/>
               </a:rPr>
-              <a:t>A sovereign AI system on your desk — with digital employees</a:t>
+              <a:t>A sovereign AI system on your desk — with digital employees that run wealth, creation, and work on metal you own.</a:t>
             </a:r>
           </a:p>
         </p:txBody>
@@ -4918,7 +4943,7 @@
         </p:nvSpPr>
         <p:spPr>
           <a:xfrm>
-            <a:off x="731520" y="3721608"/>
+            <a:off x="731520" y="3337560"/>
             <a:ext cx="10058400" cy="320040"/>
           </a:xfrm>
           <a:prstGeom prst="rect">
@@ -4953,7 +4978,7 @@
         </p:nvSpPr>
         <p:spPr>
           <a:xfrm>
-            <a:off x="731520" y="4105656"/>
+            <a:off x="731520" y="3721608"/>
             <a:ext cx="10058400" cy="320040"/>
           </a:xfrm>
           <a:prstGeom prst="rect">
@@ -4975,7 +5000,7 @@
                 </a:solidFill>
                 <a:latin typeface="Consolas"/>
               </a:rPr>
-              <a:t>$3,999 once · $0/mo operate-plane API · proof-ready · pre-revenue</a:t>
+              <a:t>$3,999 once · $0/mo operate-plane API · proof-ready on MS-S1 · pre-revenue</a:t>
             </a:r>
           </a:p>
         </p:txBody>
@@ -5010,7 +5035,7 @@
                 </a:solidFill>
                 <a:latin typeface="Segoe UI"/>
               </a:rPr>
-              <a:t>$3,999 once · $0/mo operate-plane API · proof-ready · pre-revenue</a:t>
+              <a:t>Ankur Misra · Founder &amp; CEO</a:t>
             </a:r>
           </a:p>
         </p:txBody>
@@ -5045,7 +5070,7 @@
                 </a:solidFill>
                 <a:latin typeface="Consolas"/>
               </a:rPr>
-              <a:t>v1.1.0 · July 2026 · Sovereign Agent Appliance</a:t>
+              <a:t>v1.2.0 · July 16 2026 · Sovereign Agent Appliance</a:t>
             </a:r>
           </a:p>
         </p:txBody>
@@ -5770,7 +5795,7 @@
                 <a:gridCol w="6583680"/>
                 <a:gridCol w="4389120"/>
               </a:tblGrid>
-              <a:tr h="418011">
+              <a:tr h="365760">
                 <a:tc>
                   <a:txBody>
                     <a:bodyPr/>
@@ -5808,7 +5833,7 @@
                   <a:tcPr/>
                 </a:tc>
               </a:tr>
-              <a:tr h="418011">
+              <a:tr h="365760">
                 <a:tc>
                   <a:txBody>
                     <a:bodyPr/>
@@ -5839,14 +5864,14 @@
                           </a:solidFill>
                           <a:latin typeface="Segoe UI"/>
                         </a:rPr>
-                        <a:t>G1/G2/G3 green · 239 smoke · 40 user flows</a:t>
+                        <a:t>Working appliance · 239 smoke · golden release</a:t>
                       </a:r>
                     </a:p>
                   </a:txBody>
                   <a:tcPr/>
                 </a:tc>
               </a:tr>
-              <a:tr h="418011">
+              <a:tr h="365760">
                 <a:tc>
                   <a:txBody>
                     <a:bodyPr/>
@@ -5877,14 +5902,14 @@
                           </a:solidFill>
                           <a:latin typeface="Segoe UI"/>
                         </a:rPr>
-                        <a:t>G3 demo depth · Capital paper on camera</a:t>
+                        <a:t>Demo depth · Capital paper on camera</a:t>
                       </a:r>
                     </a:p>
                   </a:txBody>
                   <a:tcPr/>
                 </a:tc>
               </a:tr>
-              <a:tr h="418011">
+              <a:tr h="365760">
                 <a:tc>
                   <a:txBody>
                     <a:bodyPr/>
@@ -5922,7 +5947,7 @@
                   <a:tcPr/>
                 </a:tc>
               </a:tr>
-              <a:tr h="418011">
+              <a:tr h="365760">
                 <a:tc>
                   <a:txBody>
                     <a:bodyPr/>
@@ -5935,7 +5960,7 @@
                           </a:solidFill>
                           <a:latin typeface="Segoe UI"/>
                         </a:rPr>
-                        <a:t>Digital bridges (Alpaca / X)</a:t>
+                        <a:t>Digital bridges (founder box)</a:t>
                       </a:r>
                     </a:p>
                   </a:txBody>
@@ -5953,14 +5978,14 @@
                           </a:solidFill>
                           <a:latin typeface="Segoe UI"/>
                         </a:rPr>
-                        <a:t>Coded · founder-keyed until Ops Wave 1</a:t>
+                        <a:t>Real receipts · not a customer fleet</a:t>
                       </a:r>
                     </a:p>
                   </a:txBody>
                   <a:tcPr/>
                 </a:tc>
               </a:tr>
-              <a:tr h="418011">
+              <a:tr h="365760">
                 <a:tc>
                   <a:txBody>
                     <a:bodyPr/>
@@ -5991,14 +6016,52 @@
                           </a:solidFill>
                           <a:latin typeface="Segoe UI"/>
                         </a:rPr>
-                        <a:t>Unboxed · G1–G3 closed · Act I proof plane</a:t>
+                        <a:t>Unboxed · Act I proof plane · film pack live</a:t>
                       </a:r>
                     </a:p>
                   </a:txBody>
                   <a:tcPr/>
                 </a:tc>
               </a:tr>
-              <a:tr h="418014">
+              <a:tr h="365760">
+                <a:tc>
+                  <a:txBody>
+                    <a:bodyPr/>
+                    <a:lstStyle/>
+                    <a:p>
+                      <a:r>
+                        <a:rPr sz="1000">
+                          <a:solidFill>
+                            <a:srgbClr val="D2D2DC"/>
+                          </a:solidFill>
+                          <a:latin typeface="Segoe UI"/>
+                        </a:rPr>
+                        <a:t>External operator UAT</a:t>
+                      </a:r>
+                    </a:p>
+                  </a:txBody>
+                  <a:tcPr/>
+                </a:tc>
+                <a:tc>
+                  <a:txBody>
+                    <a:bodyPr/>
+                    <a:lstStyle/>
+                    <a:p>
+                      <a:r>
+                        <a:rPr sz="1000">
+                          <a:solidFill>
+                            <a:srgbClr val="D2D2DC"/>
+                          </a:solidFill>
+                          <a:latin typeface="Segoe UI"/>
+                        </a:rPr>
+                        <a:t>Golden paths invite-ready · first intros in flight</a:t>
+                      </a:r>
+                    </a:p>
+                  </a:txBody>
+                  <a:tcPr/>
+                </a:tc>
+              </a:tr>
+              <a:tr h="365760">
                 <a:tc>
                   <a:txBody>
                     <a:bodyPr/>
@@ -6451,7 +6514,7 @@
                 </a:solidFill>
                 <a:latin typeface="Segoe UI"/>
               </a:rPr>
-              <a:t>Founder story — 20 days</a:t>
+              <a:t>Founder story — 20 days + follow-through</a:t>
             </a:r>
           </a:p>
         </p:txBody>
@@ -6597,7 +6660,23 @@
                 </a:solidFill>
                 <a:latin typeface="Segoe UI"/>
               </a:rPr>
-              <a:t>Week 3 — v1.0.0→v1.0.3 · G1/G2/G3 · film pack</a:t>
+              <a:t>Week 3 — v1.0.0→v1.0.3 · golden path + film pack on real metal</a:t>
+            </a:r>
+          </a:p>
+          <a:p>
+            <a:pPr>
+              <a:spcAft>
+                <a:spcPts val="600"/>
+              </a:spcAft>
+            </a:pPr>
+            <a:r>
+              <a:rPr sz="1900">
+                <a:solidFill>
+                  <a:srgbClr val="D2D2DC"/>
+                </a:solidFill>
+                <a:latin typeface="Segoe UI"/>
+              </a:rPr>
+              <a:t>Jul 9–16 — founder-box bridges · operator paths invite-ready · external intros</a:t>
             </a:r>
           </a:p>
           <a:p>
@@ -7831,7 +7910,7 @@
                 </a:solidFill>
                 <a:latin typeface="Segoe UI"/>
               </a:rPr>
-              <a:t>G1 golden path · Jul 1 — on device</a:t>
+              <a:t>Working product on MS-S1 MAX · golden path Jul 1 · release v1.0.3</a:t>
             </a:r>
           </a:p>
           <a:p>
@@ -7847,7 +7926,7 @@
                 </a:solidFill>
                 <a:latin typeface="Segoe UI"/>
               </a:rPr>
-              <a:t>G2 golden release · v1.0.0–v1.0.3</a:t>
+              <a:t>Film pack Jul 8 — inception · investor proof · desk strips</a:t>
             </a:r>
           </a:p>
           <a:p>
@@ -7863,7 +7942,7 @@
                 </a:solidFill>
                 <a:latin typeface="Segoe UI"/>
               </a:rPr>
-              <a:t>G3 film pack · Jul 8 — inception · investor proof · desk strips</a:t>
+              <a:t>239 smoke · qwen3:8b · 38 tok/s · 4.56/64 GB</a:t>
             </a:r>
           </a:p>
           <a:p>
@@ -7879,7 +7958,7 @@
                 </a:solidFill>
                 <a:latin typeface="Segoe UI"/>
               </a:rPr>
-              <a:t>239 smoke · qwen3:8b · 38 tok/s · 4.56/64 GB</a:t>
+              <a:t>Founder-box bridges — real receipts · not a customer fleet</a:t>
             </a:r>
           </a:p>
           <a:p>
@@ -7895,7 +7974,23 @@
                 </a:solidFill>
                 <a:latin typeface="Segoe UI"/>
               </a:rPr>
-              <a:t>curxor.ai live — G3 stills · /signal · press kit</a:t>
+              <a:t>Operator golden paths invite-ready · external UAT starting</a:t>
+            </a:r>
+          </a:p>
+          <a:p>
+            <a:pPr>
+              <a:spcAft>
+                <a:spcPts val="600"/>
+              </a:spcAft>
+            </a:pPr>
+            <a:r>
+              <a:rPr sz="1900">
+                <a:solidFill>
+                  <a:srgbClr val="D2D2DC"/>
+                </a:solidFill>
+                <a:latin typeface="Segoe UI"/>
+              </a:rPr>
+              <a:t>curxor.ai live — stills · /signal · press kit</a:t>
             </a:r>
           </a:p>
         </p:txBody>
@@ -9113,7 +9208,7 @@
                 </a:solidFill>
                 <a:latin typeface="Segoe UI"/>
               </a:rPr>
-              <a:t>Green — G1/G2/G3 · v1.0.3 · 239 smoke · G3 film pack</a:t>
+              <a:t>Green — working product on MS-S1 · v1.0.3 · 239 smoke · films · founder bridges</a:t>
             </a:r>
           </a:p>
           <a:p>
@@ -9129,7 +9224,7 @@
                 </a:solidFill>
                 <a:latin typeface="Segoe UI"/>
               </a:rPr>
-              <a:t>Yellow — Flagship dogfooded · paper/sim on camera · hero Act I live</a:t>
+              <a:t>Yellow — flagship dogfooded · paper/sim · invite-ready paths · first external intros</a:t>
             </a:r>
           </a:p>
           <a:p>
@@ -9177,7 +9272,7 @@
                 </a:solidFill>
                 <a:latin typeface="Segoe UI"/>
               </a:rPr>
-              <a:t>Proof-ready now · traction-ready after G4 external UAT</a:t>
+              <a:t>Proof-ready now · traction-ready after external operator smiles</a:t>
             </a:r>
           </a:p>
         </p:txBody>

</xml_diff>